<commit_message>
Pitch deck and speaking script
12-slide deck generated from the shipped artifacts, so no figure can drift
from the data: the flagship case is chosen automatically from events that
are actually flagged, and the national map is rendered from the real
621,137-record binary. Includes the two-case Exhibit A framing (the catch
and the miss) and a speaking script with demo flow and Q&A prep.

Co-Authored-By: Claude Fable 5 <noreply@anthropic.com>
</commit_message>
<xml_diff>
--- a/pitch/DISSENT_Nexus_Network_Pitch.pptx
+++ b/pitch/DISSENT_Nexus_Network_Pitch.pptx
@@ -144,11 +144,11 @@
           </c:tx>
           <c:spPr>
             <a:solidFill>
-              <a:srgbClr val="20263E"/>
+              <a:srgbClr val="16204A"/>
             </a:solidFill>
             <a:ln w="38100" cap="flat">
               <a:solidFill>
-                <a:srgbClr val="20263E"/>
+                <a:srgbClr val="16204A"/>
               </a:solidFill>
               <a:prstDash val="solid"/>
               <a:round/>
@@ -185,11 +185,11 @@
             <c:size val="6"/>
             <c:spPr>
               <a:solidFill>
-                <a:srgbClr val="20263E"/>
+                <a:srgbClr val="16204A"/>
               </a:solidFill>
               <a:ln w="9525" cap="flat">
                 <a:solidFill>
-                  <a:srgbClr val="20263E"/>
+                  <a:srgbClr val="16204A"/>
                 </a:solidFill>
                 <a:prstDash val="solid"/>
                 <a:round/>
@@ -199,9 +199,9 @@
           </c:marker>
           <c:cat>
             <c:multiLvlStrRef>
-              <c:f>Sheet1!$A$2:$A$21</c:f>
+              <c:f>Sheet1!$A$2:$A$22</c:f>
               <c:multiLvlStrCache>
-                <c:ptCount val="20"/>
+                <c:ptCount val="21"/>
                 <c:lvl>
                   <c:pt idx="0">
                     <c:v>2005</c:v>
@@ -261,6 +261,9 @@
                     <c:v>2023</c:v>
                   </c:pt>
                   <c:pt idx="19">
+                    <c:v>2024</c:v>
+                  </c:pt>
+                  <c:pt idx="20">
                     <c:v>2025</c:v>
                   </c:pt>
                 </c:lvl>
@@ -269,10 +272,10 @@
           </c:cat>
           <c:val>
             <c:numRef>
-              <c:f>Sheet1!$B$2:$B$21</c:f>
+              <c:f>Sheet1!$B$2:$B$22</c:f>
               <c:numCache>
                 <c:formatCode>General</c:formatCode>
-                <c:ptCount val="20"/>
+                <c:ptCount val="21"/>
                 <c:pt idx="0">
                   <c:v>5</c:v>
                 </c:pt>
@@ -331,6 +334,9 @@
                   <c:v>8</c:v>
                 </c:pt>
                 <c:pt idx="19">
+                  <c:v/>
+                </c:pt>
+                <c:pt idx="20">
                   <c:v>3</c:v>
                 </c:pt>
               </c:numCache>
@@ -409,9 +415,9 @@
           </c:marker>
           <c:cat>
             <c:multiLvlStrRef>
-              <c:f>Sheet1!$A$2:$A$21</c:f>
+              <c:f>Sheet1!$A$2:$A$22</c:f>
               <c:multiLvlStrCache>
-                <c:ptCount val="20"/>
+                <c:ptCount val="21"/>
                 <c:lvl>
                   <c:pt idx="0">
                     <c:v>2005</c:v>
@@ -471,6 +477,9 @@
                     <c:v>2023</c:v>
                   </c:pt>
                   <c:pt idx="19">
+                    <c:v>2024</c:v>
+                  </c:pt>
+                  <c:pt idx="20">
                     <c:v>2025</c:v>
                   </c:pt>
                 </c:lvl>
@@ -479,10 +488,10 @@
           </c:cat>
           <c:val>
             <c:numRef>
-              <c:f>Sheet1!$C$2:$C$21</c:f>
+              <c:f>Sheet1!$C$2:$C$22</c:f>
               <c:numCache>
                 <c:formatCode>General</c:formatCode>
-                <c:ptCount val="20"/>
+                <c:ptCount val="21"/>
                 <c:pt idx="0">
                   <c:v>5.34</c:v>
                 </c:pt>
@@ -541,6 +550,9 @@
                   <c:v>5.83</c:v>
                 </c:pt>
                 <c:pt idx="19">
+                  <c:v/>
+                </c:pt>
+                <c:pt idx="20">
                   <c:v>6.11</c:v>
                 </c:pt>
               </c:numCache>
@@ -623,7 +635,7 @@
         <c:scaling>
           <c:orientation val="minMax"/>
           <c:max val="9"/>
-          <c:min val="0"/>
+          <c:min val="2"/>
         </c:scaling>
         <c:delete val="0"/>
         <c:axPos val="l"/>
@@ -669,7 +681,7 @@
         <c:crossAx val="2094734554"/>
         <c:crosses val="autoZero"/>
         <c:crossBetween val="between"/>
-        <c:majorUnit val="3"/>
+        <c:majorUnit val="1"/>
       </c:valAx>
       <c:spPr>
         <a:solidFill>
@@ -2160,7 +2172,7 @@
         </p:nvSpPr>
         <p:spPr>
           <a:xfrm>
-            <a:off x="11640312" y="6537960"/>
+            <a:off x="11622024" y="6510528"/>
             <a:ext cx="800000" cy="300000"/>
           </a:xfrm>
           <a:prstGeom prst="rect">
@@ -2178,7 +2190,7 @@
             <a:lvl1pPr>
               <a:defRPr sz="900">
                 <a:solidFill>
-                  <a:srgbClr val="8A93B8"/>
+                  <a:srgbClr val="5C6795"/>
                 </a:solidFill>
                 <a:latin typeface="Courier New"/>
                 <a:ea typeface="Courier New"/>
@@ -2233,7 +2245,7 @@
         </p:nvSpPr>
         <p:spPr>
           <a:xfrm>
-            <a:off x="11640312" y="6537960"/>
+            <a:off x="11622024" y="6510528"/>
             <a:ext cx="800000" cy="300000"/>
           </a:xfrm>
           <a:prstGeom prst="rect">
@@ -2251,7 +2263,7 @@
             <a:lvl1pPr>
               <a:defRPr sz="900">
                 <a:solidFill>
-                  <a:srgbClr val="8A93B8"/>
+                  <a:srgbClr val="5C6795"/>
                 </a:solidFill>
                 <a:latin typeface="Courier New"/>
                 <a:ea typeface="Courier New"/>
@@ -2563,7 +2575,7 @@
         </p:nvPicPr>
         <p:blipFill>
           <a:blip r:embed="rId1">
-            <a:alphaModFix amt="38000"/>
+            <a:alphaModFix amt="72000"/>
           </a:blip>
           <a:stretch>
             <a:fillRect/>
@@ -2571,8 +2583,8 @@
         </p:blipFill>
         <p:spPr>
           <a:xfrm>
-            <a:off x="0" y="1371600"/>
-            <a:ext cx="12188952" cy="5486400"/>
+            <a:off x="0" y="502920"/>
+            <a:ext cx="12188952" cy="6656832"/>
           </a:xfrm>
           <a:prstGeom prst="rect">
             <a:avLst/>
@@ -2637,10 +2649,10 @@
           <a:ln/>
         </p:spPr>
         <p:txBody>
-          <a:bodyPr wrap="square" lIns="0" tIns="0" rIns="0" bIns="0" rtlCol="0" anchor="ctr"/>
-          <a:lstStyle/>
-          <a:p>
-            <a:pPr indent="0" marL="0">
+          <a:bodyPr wrap="square" lIns="0" tIns="0" rIns="0" bIns="0" rtlCol="0" anchor="t"/>
+          <a:lstStyle/>
+          <a:p>
+            <a:pPr algn="l" indent="0" marL="0">
               <a:buNone/>
             </a:pPr>
             <a:r>
@@ -2745,19 +2757,19 @@
         <p:spPr>
           <a:xfrm>
             <a:off x="594360" y="6327648"/>
-            <a:ext cx="8686800" cy="228600"/>
-          </a:xfrm>
-          <a:prstGeom prst="rect">
-            <a:avLst/>
-          </a:prstGeom>
-          <a:noFill/>
-          <a:ln/>
-        </p:spPr>
-        <p:txBody>
-          <a:bodyPr wrap="square" lIns="0" tIns="0" rIns="0" bIns="0" rtlCol="0" anchor="ctr"/>
-          <a:lstStyle/>
-          <a:p>
-            <a:pPr indent="0" marL="0">
+            <a:ext cx="5669280" cy="228600"/>
+          </a:xfrm>
+          <a:prstGeom prst="rect">
+            <a:avLst/>
+          </a:prstGeom>
+          <a:noFill/>
+          <a:ln/>
+        </p:spPr>
+        <p:txBody>
+          <a:bodyPr wrap="square" lIns="0" tIns="0" rIns="0" bIns="0" rtlCol="0" anchor="t"/>
+          <a:lstStyle/>
+          <a:p>
+            <a:pPr algn="l" indent="0" marL="0">
               <a:buNone/>
             </a:pPr>
             <a:r>
@@ -2769,7 +2781,7 @@
                 <a:ea typeface="Courier New" pitchFamily="34" charset="-122"/>
                 <a:cs typeface="Courier New" pitchFamily="34" charset="-120"/>
               </a:rPr>
-              <a:t>EVERY RATED BRIDGE IN THE UNITED STATES  ·  621,137 STRUCTURES  ·  41,319 RATED POOR</a:t>
+              <a:t>621,137 STRUCTURES  ·  41,319 RATED POOR</a:t>
             </a:r>
             <a:endParaRPr lang="en-US" sz="1050" dirty="0"/>
           </a:p>
@@ -2822,20 +2834,20 @@
         </p:nvSpPr>
         <p:spPr>
           <a:xfrm>
-            <a:off x="8394192" y="6327648"/>
-            <a:ext cx="3200400" cy="228600"/>
-          </a:xfrm>
-          <a:prstGeom prst="rect">
-            <a:avLst/>
-          </a:prstGeom>
-          <a:noFill/>
-          <a:ln/>
-        </p:spPr>
-        <p:txBody>
-          <a:bodyPr wrap="square" lIns="0" tIns="0" rIns="0" bIns="0" rtlCol="0" anchor="ctr"/>
-          <a:lstStyle/>
-          <a:p>
-            <a:pPr indent="0" marL="0">
+            <a:off x="7754112" y="6327648"/>
+            <a:ext cx="3840480" cy="228600"/>
+          </a:xfrm>
+          <a:prstGeom prst="rect">
+            <a:avLst/>
+          </a:prstGeom>
+          <a:noFill/>
+          <a:ln/>
+        </p:spPr>
+        <p:txBody>
+          <a:bodyPr wrap="square" lIns="0" tIns="0" rIns="0" bIns="0" rtlCol="0" anchor="t"/>
+          <a:lstStyle/>
+          <a:p>
+            <a:pPr algn="r" indent="0" marL="0">
               <a:buNone/>
             </a:pPr>
             <a:r>
@@ -2865,7 +2877,7 @@
         </p:nvSpPr>
         <p:spPr>
           <a:xfrm>
-            <a:off x="11640312" y="6537960"/>
+            <a:off x="11622024" y="6510528"/>
             <a:ext cx="800000" cy="300000"/>
           </a:xfrm>
           <a:prstGeom prst="rect">
@@ -2883,7 +2895,7 @@
             <a:lvl1pPr>
               <a:defRPr sz="900">
                 <a:solidFill>
-                  <a:srgbClr val="8A93B8"/>
+                  <a:srgbClr val="5C6795"/>
                 </a:solidFill>
                 <a:latin typeface="Courier New"/>
                 <a:ea typeface="Courier New"/>
@@ -2951,10 +2963,10 @@
           <a:ln/>
         </p:spPr>
         <p:txBody>
-          <a:bodyPr wrap="square" lIns="0" tIns="0" rIns="0" bIns="0" rtlCol="0" anchor="ctr"/>
-          <a:lstStyle/>
-          <a:p>
-            <a:pPr indent="0" marL="0">
+          <a:bodyPr wrap="square" lIns="0" tIns="0" rIns="0" bIns="0" rtlCol="0" anchor="t"/>
+          <a:lstStyle/>
+          <a:p>
+            <a:pPr algn="l" indent="0" marL="0">
               <a:buNone/>
             </a:pPr>
             <a:r>
@@ -3086,17 +3098,17 @@
         </p:nvSpPr>
         <p:spPr>
           <a:xfrm>
-            <a:off x="795528" y="2286000"/>
-            <a:ext cx="4754880" cy="960120"/>
-          </a:xfrm>
-          <a:prstGeom prst="rect">
-            <a:avLst/>
-          </a:prstGeom>
-          <a:noFill/>
-          <a:ln/>
-        </p:spPr>
-        <p:txBody>
-          <a:bodyPr wrap="square" lIns="0" tIns="0" rIns="0" bIns="0" rtlCol="0" anchor="ctr"/>
+            <a:off x="795528" y="2258568"/>
+            <a:ext cx="4754880" cy="1051560"/>
+          </a:xfrm>
+          <a:prstGeom prst="rect">
+            <a:avLst/>
+          </a:prstGeom>
+          <a:noFill/>
+          <a:ln/>
+        </p:spPr>
+        <p:txBody>
+          <a:bodyPr wrap="square" lIns="0" tIns="0" rIns="0" bIns="0" rtlCol="0" anchor="t"/>
           <a:lstStyle/>
           <a:p>
             <a:pPr indent="0" marL="0">
@@ -3114,7 +3126,7 @@
                 <a:ea typeface="Calibri" pitchFamily="34" charset="-122"/>
                 <a:cs typeface="Calibri" pitchFamily="34" charset="-120"/>
               </a:rPr>
-              <a:t>Structures newer than five years sit outside the model’s training support, so it issues no verdict on them at all — 81 of them in Rhode Island alone.</a:t>
+              <a:t>Structures newer than five years sit outside the model’s training support, so it issues no verdict on them at all: 81 of them in Rhode Island alone.</a:t>
             </a:r>
             <a:endParaRPr lang="en-US" sz="1200" dirty="0"/>
           </a:p>
@@ -3192,17 +3204,17 @@
         </p:nvSpPr>
         <p:spPr>
           <a:xfrm>
-            <a:off x="6327648" y="2286000"/>
-            <a:ext cx="4754880" cy="960120"/>
-          </a:xfrm>
-          <a:prstGeom prst="rect">
-            <a:avLst/>
-          </a:prstGeom>
-          <a:noFill/>
-          <a:ln/>
-        </p:spPr>
-        <p:txBody>
-          <a:bodyPr wrap="square" lIns="0" tIns="0" rIns="0" bIns="0" rtlCol="0" anchor="ctr"/>
+            <a:off x="6327648" y="2258568"/>
+            <a:ext cx="4754880" cy="1051560"/>
+          </a:xfrm>
+          <a:prstGeom prst="rect">
+            <a:avLst/>
+          </a:prstGeom>
+          <a:noFill/>
+          <a:ln/>
+        </p:spPr>
+        <p:txBody>
+          <a:bodyPr wrap="square" lIns="0" tIns="0" rIns="0" bIns="0" rtlCol="0" anchor="t"/>
           <a:lstStyle/>
           <a:p>
             <a:pPr indent="0" marL="0">
@@ -3298,17 +3310,17 @@
         </p:nvSpPr>
         <p:spPr>
           <a:xfrm>
-            <a:off x="795528" y="4251960"/>
-            <a:ext cx="4754880" cy="960120"/>
-          </a:xfrm>
-          <a:prstGeom prst="rect">
-            <a:avLst/>
-          </a:prstGeom>
-          <a:noFill/>
-          <a:ln/>
-        </p:spPr>
-        <p:txBody>
-          <a:bodyPr wrap="square" lIns="0" tIns="0" rIns="0" bIns="0" rtlCol="0" anchor="ctr"/>
+            <a:off x="795528" y="4224528"/>
+            <a:ext cx="4754880" cy="1051560"/>
+          </a:xfrm>
+          <a:prstGeom prst="rect">
+            <a:avLst/>
+          </a:prstGeom>
+          <a:noFill/>
+          <a:ln/>
+        </p:spPr>
+        <p:txBody>
+          <a:bodyPr wrap="square" lIns="0" tIns="0" rIns="0" bIns="0" rtlCol="0" anchor="t"/>
           <a:lstStyle/>
           <a:p>
             <a:pPr indent="0" marL="0">
@@ -3404,17 +3416,17 @@
         </p:nvSpPr>
         <p:spPr>
           <a:xfrm>
-            <a:off x="6327648" y="4251960"/>
-            <a:ext cx="4754880" cy="960120"/>
-          </a:xfrm>
-          <a:prstGeom prst="rect">
-            <a:avLst/>
-          </a:prstGeom>
-          <a:noFill/>
-          <a:ln/>
-        </p:spPr>
-        <p:txBody>
-          <a:bodyPr wrap="square" lIns="0" tIns="0" rIns="0" bIns="0" rtlCol="0" anchor="ctr"/>
+            <a:off x="6327648" y="4224528"/>
+            <a:ext cx="4754880" cy="1051560"/>
+          </a:xfrm>
+          <a:prstGeom prst="rect">
+            <a:avLst/>
+          </a:prstGeom>
+          <a:noFill/>
+          <a:ln/>
+        </p:spPr>
+        <p:txBody>
+          <a:bodyPr wrap="square" lIns="0" tIns="0" rIns="0" bIns="0" rtlCol="0" anchor="t"/>
           <a:lstStyle/>
           <a:p>
             <a:pPr indent="0" marL="0">
@@ -3432,7 +3444,7 @@
                 <a:ea typeface="Calibri" pitchFamily="34" charset="-122"/>
                 <a:cs typeface="Calibri" pitchFamily="34" charset="-120"/>
               </a:rPr>
-              <a:t>No free processed radar covers these states, so the replay demonstrates that detector on a published record instead — and cites the paper that disputes it.</a:t>
+              <a:t>No free processed radar covers these states, so the replay demonstrates that detector against a published finding instead, and cites the paper that disputes it.</a:t>
             </a:r>
             <a:endParaRPr lang="en-US" sz="1200" dirty="0"/>
           </a:p>
@@ -3474,6 +3486,54 @@
               <a:t>A tool that audits records has to be auditable itself.</a:t>
             </a:r>
             <a:endParaRPr lang="en-US" sz="1700" dirty="0"/>
+          </a:p>
+        </p:txBody>
+      </p:sp>
+      <p:sp>
+        <p:nvSpPr>
+          <p:cNvPr id="25" name="Slide Number Placeholder 0"/>
+          <p:cNvSpPr>
+            <a:spLocks noGrp="1"/>
+          </p:cNvSpPr>
+          <p:nvPr>
+            <p:ph type="sldNum" sz="quarter" idx="4294967295"/>
+          </p:nvPr>
+        </p:nvSpPr>
+        <p:spPr>
+          <a:xfrm>
+            <a:off x="11622024" y="6510528"/>
+            <a:ext cx="800000" cy="300000"/>
+          </a:xfrm>
+          <a:prstGeom prst="rect">
+            <a:avLst/>
+          </a:prstGeom>
+          <a:extLst>
+            <a:ext uri="{C572A759-6A51-4108-AA02-DFA0A04FC94B}">
+              <ma14:wrappingTextBoxFlag xmlns:ma14="http://schemas.microsoft.com/office/mac/drawingml/2011/main" val="0"/>
+            </a:ext>
+          </a:extLst>
+        </p:spPr>
+        <p:txBody>
+          <a:bodyPr/>
+          <a:lstStyle>
+            <a:lvl1pPr>
+              <a:defRPr sz="900">
+                <a:solidFill>
+                  <a:srgbClr val="B3AC9A"/>
+                </a:solidFill>
+                <a:latin typeface="Courier New"/>
+                <a:ea typeface="Courier New"/>
+                <a:cs typeface="Courier New"/>
+              </a:defRPr>
+            </a:lvl1pPr>
+          </a:lstStyle>
+          <a:p>
+            <a:pPr algn="l"/>
+            <a:fld id="{F7021451-1387-4CA6-816F-3879F97B5CBC}" type="slidenum">
+              <a:rPr b="0" lang="en-US"/>
+              <a:t>10</a:t>
+            </a:fld>
+            <a:endParaRPr lang="en-US"/>
           </a:p>
         </p:txBody>
       </p:sp>
@@ -3527,16 +3587,16 @@
           <a:ln/>
         </p:spPr>
         <p:txBody>
-          <a:bodyPr wrap="square" lIns="0" tIns="0" rIns="0" bIns="0" rtlCol="0" anchor="ctr"/>
-          <a:lstStyle/>
-          <a:p>
-            <a:pPr indent="0" marL="0">
+          <a:bodyPr wrap="square" lIns="0" tIns="0" rIns="0" bIns="0" rtlCol="0" anchor="t"/>
+          <a:lstStyle/>
+          <a:p>
+            <a:pPr algn="l" indent="0" marL="0">
               <a:buNone/>
             </a:pPr>
             <a:r>
               <a:rPr lang="en-US" sz="1050" spc="120" kern="0" dirty="0">
                 <a:solidFill>
-                  <a:srgbClr val="C6283C"/>
+                  <a:srgbClr val="E4607A"/>
                 </a:solidFill>
                 <a:latin typeface="Courier New" pitchFamily="34" charset="0"/>
                 <a:ea typeface="Courier New" pitchFamily="34" charset="-122"/>
@@ -3619,7 +3679,7 @@
         <p:spPr>
           <a:xfrm>
             <a:off x="594360" y="2651760"/>
-            <a:ext cx="3291840" cy="1371600"/>
+            <a:ext cx="3322015" cy="1371600"/>
           </a:xfrm>
           <a:prstGeom prst="rect">
             <a:avLst/>
@@ -3682,17 +3742,17 @@
         </p:nvSpPr>
         <p:spPr>
           <a:xfrm>
-            <a:off x="777240" y="3291840"/>
-            <a:ext cx="2926080" cy="548640"/>
-          </a:xfrm>
-          <a:prstGeom prst="rect">
-            <a:avLst/>
-          </a:prstGeom>
-          <a:noFill/>
-          <a:ln/>
-        </p:spPr>
-        <p:txBody>
-          <a:bodyPr wrap="square" lIns="0" tIns="0" rIns="0" bIns="0" rtlCol="0" anchor="ctr"/>
+            <a:off x="777240" y="3273552"/>
+            <a:ext cx="2971800" cy="566928"/>
+          </a:xfrm>
+          <a:prstGeom prst="rect">
+            <a:avLst/>
+          </a:prstGeom>
+          <a:noFill/>
+          <a:ln/>
+        </p:spPr>
+        <p:txBody>
+          <a:bodyPr wrap="square" lIns="0" tIns="0" rIns="0" bIns="0" rtlCol="0" anchor="t"/>
           <a:lstStyle/>
           <a:p>
             <a:pPr indent="0" marL="0">
@@ -3744,8 +3804,8 @@
         </p:nvSpPr>
         <p:spPr>
           <a:xfrm>
-            <a:off x="4251960" y="2651760"/>
-            <a:ext cx="3291840" cy="1371600"/>
+            <a:off x="4282135" y="2651760"/>
+            <a:ext cx="3322015" cy="1371600"/>
           </a:xfrm>
           <a:prstGeom prst="rect">
             <a:avLst/>
@@ -3769,7 +3829,7 @@
         </p:nvSpPr>
         <p:spPr>
           <a:xfrm>
-            <a:off x="4434840" y="2788920"/>
+            <a:off x="4465015" y="2788920"/>
             <a:ext cx="2926080" cy="457200"/>
           </a:xfrm>
           <a:prstGeom prst="rect">
@@ -3808,17 +3868,17 @@
         </p:nvSpPr>
         <p:spPr>
           <a:xfrm>
-            <a:off x="4434840" y="3291840"/>
-            <a:ext cx="2926080" cy="548640"/>
-          </a:xfrm>
-          <a:prstGeom prst="rect">
-            <a:avLst/>
-          </a:prstGeom>
-          <a:noFill/>
-          <a:ln/>
-        </p:spPr>
-        <p:txBody>
-          <a:bodyPr wrap="square" lIns="0" tIns="0" rIns="0" bIns="0" rtlCol="0" anchor="ctr"/>
+            <a:off x="4465015" y="3273552"/>
+            <a:ext cx="2971800" cy="566928"/>
+          </a:xfrm>
+          <a:prstGeom prst="rect">
+            <a:avLst/>
+          </a:prstGeom>
+          <a:noFill/>
+          <a:ln/>
+        </p:spPr>
+        <p:txBody>
+          <a:bodyPr wrap="square" lIns="0" tIns="0" rIns="0" bIns="0" rtlCol="0" anchor="t"/>
           <a:lstStyle/>
           <a:p>
             <a:pPr indent="0" marL="0">
@@ -3870,8 +3930,8 @@
         </p:nvSpPr>
         <p:spPr>
           <a:xfrm>
-            <a:off x="7909560" y="2651760"/>
-            <a:ext cx="3291840" cy="1371600"/>
+            <a:off x="7969910" y="2651760"/>
+            <a:ext cx="3322015" cy="1371600"/>
           </a:xfrm>
           <a:prstGeom prst="rect">
             <a:avLst/>
@@ -3895,7 +3955,7 @@
         </p:nvSpPr>
         <p:spPr>
           <a:xfrm>
-            <a:off x="8092440" y="2788920"/>
+            <a:off x="8152790" y="2788920"/>
             <a:ext cx="2926080" cy="457200"/>
           </a:xfrm>
           <a:prstGeom prst="rect">
@@ -3934,17 +3994,17 @@
         </p:nvSpPr>
         <p:spPr>
           <a:xfrm>
-            <a:off x="8092440" y="3291840"/>
-            <a:ext cx="2926080" cy="548640"/>
-          </a:xfrm>
-          <a:prstGeom prst="rect">
-            <a:avLst/>
-          </a:prstGeom>
-          <a:noFill/>
-          <a:ln/>
-        </p:spPr>
-        <p:txBody>
-          <a:bodyPr wrap="square" lIns="0" tIns="0" rIns="0" bIns="0" rtlCol="0" anchor="ctr"/>
+            <a:off x="8152790" y="3273552"/>
+            <a:ext cx="2971800" cy="566928"/>
+          </a:xfrm>
+          <a:prstGeom prst="rect">
+            <a:avLst/>
+          </a:prstGeom>
+          <a:noFill/>
+          <a:ln/>
+        </p:spPr>
+        <p:txBody>
+          <a:bodyPr wrap="square" lIns="0" tIns="0" rIns="0" bIns="0" rtlCol="0" anchor="t"/>
           <a:lstStyle/>
           <a:p>
             <a:pPr indent="0" marL="0">
@@ -4045,11 +4105,11 @@
             <a:avLst/>
           </a:prstGeom>
           <a:solidFill>
-            <a:srgbClr val="0F1738"/>
+            <a:srgbClr val="1E2A5C"/>
           </a:solidFill>
           <a:ln w="9525">
             <a:solidFill>
-              <a:srgbClr val="0F1738"/>
+              <a:srgbClr val="1E2A5C"/>
             </a:solidFill>
             <a:prstDash val="solid"/>
           </a:ln>
@@ -4130,9 +4190,57 @@
                 <a:ea typeface="Calibri" pitchFamily="34" charset="-122"/>
                 <a:cs typeface="Calibri" pitchFamily="34" charset="-120"/>
               </a:rPr>
-              <a:t>IBMS already inventories 172,517 National Highway structures on the same 0–9 idea, and MoRTH’s nationwide digital re-survey is creating exactly the fresh paper baseline this method audits. Morbi — 135 dead, four days after a renovation nobody checked against the physical bridge — is the failure mode, precisely.</a:t>
+              <a:t>IBMS already inventories 172,517 National Highway structures on the same 0–9 idea, and MoRTH’s nationwide digital re-survey is creating exactly the fresh paper baseline this method audits. Morbi, 135 dead four days after a renovation nobody checked against the physical bridge, is that failure mode precisely.</a:t>
             </a:r>
             <a:endParaRPr lang="en-US" sz="1200" dirty="0"/>
+          </a:p>
+        </p:txBody>
+      </p:sp>
+      <p:sp>
+        <p:nvSpPr>
+          <p:cNvPr id="25" name="Slide Number Placeholder 0"/>
+          <p:cNvSpPr>
+            <a:spLocks noGrp="1"/>
+          </p:cNvSpPr>
+          <p:nvPr>
+            <p:ph type="sldNum" sz="quarter" idx="4294967295"/>
+          </p:nvPr>
+        </p:nvSpPr>
+        <p:spPr>
+          <a:xfrm>
+            <a:off x="11622024" y="6510528"/>
+            <a:ext cx="800000" cy="300000"/>
+          </a:xfrm>
+          <a:prstGeom prst="rect">
+            <a:avLst/>
+          </a:prstGeom>
+          <a:extLst>
+            <a:ext uri="{C572A759-6A51-4108-AA02-DFA0A04FC94B}">
+              <ma14:wrappingTextBoxFlag xmlns:ma14="http://schemas.microsoft.com/office/mac/drawingml/2011/main" val="0"/>
+            </a:ext>
+          </a:extLst>
+        </p:spPr>
+        <p:txBody>
+          <a:bodyPr/>
+          <a:lstStyle>
+            <a:lvl1pPr>
+              <a:defRPr sz="900">
+                <a:solidFill>
+                  <a:srgbClr val="5C6795"/>
+                </a:solidFill>
+                <a:latin typeface="Courier New"/>
+                <a:ea typeface="Courier New"/>
+                <a:cs typeface="Courier New"/>
+              </a:defRPr>
+            </a:lvl1pPr>
+          </a:lstStyle>
+          <a:p>
+            <a:pPr algn="l"/>
+            <a:fld id="{F7021451-1387-4CA6-816F-3879F97B5CBC}" type="slidenum">
+              <a:rPr b="0" lang="en-US"/>
+              <a:t>11</a:t>
+            </a:fld>
+            <a:endParaRPr lang="en-US"/>
           </a:p>
         </p:txBody>
       </p:sp>
@@ -4219,7 +4327,7 @@
         <p:spPr>
           <a:xfrm>
             <a:off x="594360" y="2331720"/>
-            <a:ext cx="10607040" cy="548640"/>
+            <a:ext cx="10972800" cy="548640"/>
           </a:xfrm>
           <a:prstGeom prst="rect">
             <a:avLst/>
@@ -4246,7 +4354,7 @@
                 <a:ea typeface="Cambria" pitchFamily="34" charset="-122"/>
                 <a:cs typeface="Cambria" pitchFamily="34" charset="-120"/>
               </a:rPr>
-              <a:t>It fails contradicted. DISSENT is the machine that files the dissent.</a:t>
+              <a:t>It fails contradicted. DISSENT files that contradiction.</a:t>
             </a:r>
             <a:endParaRPr lang="en-US" sz="3000" dirty="0"/>
           </a:p>
@@ -4465,10 +4573,10 @@
           <a:ln/>
         </p:spPr>
         <p:txBody>
-          <a:bodyPr wrap="square" lIns="0" tIns="0" rIns="0" bIns="0" rtlCol="0" anchor="ctr"/>
-          <a:lstStyle/>
-          <a:p>
-            <a:pPr indent="0" marL="0">
+          <a:bodyPr wrap="square" lIns="0" tIns="0" rIns="0" bIns="0" rtlCol="0" anchor="t"/>
+          <a:lstStyle/>
+          <a:p>
+            <a:pPr algn="r" indent="0" marL="0">
               <a:buNone/>
             </a:pPr>
             <a:r>
@@ -4504,10 +4612,10 @@
           <a:ln/>
         </p:spPr>
         <p:txBody>
-          <a:bodyPr wrap="square" lIns="0" tIns="0" rIns="0" bIns="0" rtlCol="0" anchor="ctr"/>
-          <a:lstStyle/>
-          <a:p>
-            <a:pPr indent="0" marL="0">
+          <a:bodyPr wrap="square" lIns="0" tIns="0" rIns="0" bIns="0" rtlCol="0" anchor="t"/>
+          <a:lstStyle/>
+          <a:p>
+            <a:pPr algn="l" indent="0" marL="0">
               <a:buNone/>
             </a:pPr>
             <a:r>
@@ -4522,6 +4630,54 @@
               <a:t>234,801 REAL FILINGS  ·  621,137 STRUCTURES MAPPED  ·  NOT ONE INVENTED NUMBER</a:t>
             </a:r>
             <a:endParaRPr lang="en-US" sz="1050" dirty="0"/>
+          </a:p>
+        </p:txBody>
+      </p:sp>
+      <p:sp>
+        <p:nvSpPr>
+          <p:cNvPr id="25" name="Slide Number Placeholder 0"/>
+          <p:cNvSpPr>
+            <a:spLocks noGrp="1"/>
+          </p:cNvSpPr>
+          <p:nvPr>
+            <p:ph type="sldNum" sz="quarter" idx="4294967295"/>
+          </p:nvPr>
+        </p:nvSpPr>
+        <p:spPr>
+          <a:xfrm>
+            <a:off x="11622024" y="6510528"/>
+            <a:ext cx="800000" cy="300000"/>
+          </a:xfrm>
+          <a:prstGeom prst="rect">
+            <a:avLst/>
+          </a:prstGeom>
+          <a:extLst>
+            <a:ext uri="{C572A759-6A51-4108-AA02-DFA0A04FC94B}">
+              <ma14:wrappingTextBoxFlag xmlns:ma14="http://schemas.microsoft.com/office/mac/drawingml/2011/main" val="0"/>
+            </a:ext>
+          </a:extLst>
+        </p:spPr>
+        <p:txBody>
+          <a:bodyPr/>
+          <a:lstStyle>
+            <a:lvl1pPr>
+              <a:defRPr sz="900">
+                <a:solidFill>
+                  <a:srgbClr val="5C6795"/>
+                </a:solidFill>
+                <a:latin typeface="Courier New"/>
+                <a:ea typeface="Courier New"/>
+                <a:cs typeface="Courier New"/>
+              </a:defRPr>
+            </a:lvl1pPr>
+          </a:lstStyle>
+          <a:p>
+            <a:pPr algn="l"/>
+            <a:fld id="{F7021451-1387-4CA6-816F-3879F97B5CBC}" type="slidenum">
+              <a:rPr b="0" lang="en-US"/>
+              <a:t>12</a:t>
+            </a:fld>
+            <a:endParaRPr lang="en-US"/>
           </a:p>
         </p:txBody>
       </p:sp>
@@ -4575,16 +4731,16 @@
           <a:ln/>
         </p:spPr>
         <p:txBody>
-          <a:bodyPr wrap="square" lIns="0" tIns="0" rIns="0" bIns="0" rtlCol="0" anchor="ctr"/>
-          <a:lstStyle/>
-          <a:p>
-            <a:pPr indent="0" marL="0">
+          <a:bodyPr wrap="square" lIns="0" tIns="0" rIns="0" bIns="0" rtlCol="0" anchor="t"/>
+          <a:lstStyle/>
+          <a:p>
+            <a:pPr algn="l" indent="0" marL="0">
               <a:buNone/>
             </a:pPr>
             <a:r>
               <a:rPr lang="en-US" sz="1050" spc="120" kern="0" dirty="0">
                 <a:solidFill>
-                  <a:srgbClr val="C6283C"/>
+                  <a:srgbClr val="E4607A"/>
                 </a:solidFill>
                 <a:latin typeface="Courier New" pitchFamily="34" charset="0"/>
                 <a:ea typeface="Courier New" pitchFamily="34" charset="-122"/>
@@ -4694,7 +4850,7 @@
                 <a:ea typeface="Calibri" pitchFamily="34" charset="-122"/>
                 <a:cs typeface="Calibri" pitchFamily="34" charset="-120"/>
               </a:rPr>
-              <a:t>It fails the day the paperwork and the physical bridge stop agreeing — and nobody is looking at both.</a:t>
+              <a:t>It fails the day the paperwork and the physical bridge stop agreeing, and nobody is looking at both.</a:t>
             </a:r>
             <a:endParaRPr lang="en-US" sz="1700" dirty="0"/>
           </a:p>
@@ -4727,7 +4883,7 @@
             <a:r>
               <a:rPr lang="en-US" sz="2700" b="1" dirty="0">
                 <a:solidFill>
-                  <a:srgbClr val="C6283C"/>
+                  <a:srgbClr val="E4607A"/>
                 </a:solidFill>
                 <a:latin typeface="Cambria" pitchFamily="34" charset="0"/>
                 <a:ea typeface="Cambria" pitchFamily="34" charset="-122"/>
@@ -4747,17 +4903,17 @@
         </p:nvSpPr>
         <p:spPr>
           <a:xfrm>
-            <a:off x="2743200" y="3758184"/>
-            <a:ext cx="8595360" cy="731520"/>
-          </a:xfrm>
-          <a:prstGeom prst="rect">
-            <a:avLst/>
-          </a:prstGeom>
-          <a:noFill/>
-          <a:ln/>
-        </p:spPr>
-        <p:txBody>
-          <a:bodyPr wrap="square" lIns="0" tIns="0" rIns="0" bIns="0" rtlCol="0" anchor="ctr"/>
+            <a:off x="2743200" y="3739896"/>
+            <a:ext cx="8595360" cy="566928"/>
+          </a:xfrm>
+          <a:prstGeom prst="rect">
+            <a:avLst/>
+          </a:prstGeom>
+          <a:noFill/>
+          <a:ln/>
+        </p:spPr>
+        <p:txBody>
+          <a:bodyPr wrap="square" lIns="0" tIns="0" rIns="0" bIns="0" rtlCol="0" anchor="t"/>
           <a:lstStyle/>
           <a:p>
             <a:pPr indent="0" marL="0">
@@ -4808,7 +4964,7 @@
             <a:r>
               <a:rPr lang="en-US" sz="2700" b="1" dirty="0">
                 <a:solidFill>
-                  <a:srgbClr val="C6283C"/>
+                  <a:srgbClr val="E4607A"/>
                 </a:solidFill>
                 <a:latin typeface="Cambria" pitchFamily="34" charset="0"/>
                 <a:ea typeface="Cambria" pitchFamily="34" charset="-122"/>
@@ -4828,17 +4984,17 @@
         </p:nvSpPr>
         <p:spPr>
           <a:xfrm>
-            <a:off x="2743200" y="4690872"/>
-            <a:ext cx="8595360" cy="731520"/>
-          </a:xfrm>
-          <a:prstGeom prst="rect">
-            <a:avLst/>
-          </a:prstGeom>
-          <a:noFill/>
-          <a:ln/>
-        </p:spPr>
-        <p:txBody>
-          <a:bodyPr wrap="square" lIns="0" tIns="0" rIns="0" bIns="0" rtlCol="0" anchor="ctr"/>
+            <a:off x="2743200" y="4672584"/>
+            <a:ext cx="8595360" cy="566928"/>
+          </a:xfrm>
+          <a:prstGeom prst="rect">
+            <a:avLst/>
+          </a:prstGeom>
+          <a:noFill/>
+          <a:ln/>
+        </p:spPr>
+        <p:txBody>
+          <a:bodyPr wrap="square" lIns="0" tIns="0" rIns="0" bIns="0" rtlCol="0" anchor="t"/>
           <a:lstStyle/>
           <a:p>
             <a:pPr indent="0" marL="0">
@@ -4889,7 +5045,7 @@
             <a:r>
               <a:rPr lang="en-US" sz="2700" b="1" dirty="0">
                 <a:solidFill>
-                  <a:srgbClr val="C6283C"/>
+                  <a:srgbClr val="E4607A"/>
                 </a:solidFill>
                 <a:latin typeface="Cambria" pitchFamily="34" charset="0"/>
                 <a:ea typeface="Cambria" pitchFamily="34" charset="-122"/>
@@ -4909,17 +5065,17 @@
         </p:nvSpPr>
         <p:spPr>
           <a:xfrm>
-            <a:off x="2743200" y="5623560"/>
-            <a:ext cx="8595360" cy="731520"/>
-          </a:xfrm>
-          <a:prstGeom prst="rect">
-            <a:avLst/>
-          </a:prstGeom>
-          <a:noFill/>
-          <a:ln/>
-        </p:spPr>
-        <p:txBody>
-          <a:bodyPr wrap="square" lIns="0" tIns="0" rIns="0" bIns="0" rtlCol="0" anchor="ctr"/>
+            <a:off x="2743200" y="5605272"/>
+            <a:ext cx="8595360" cy="566928"/>
+          </a:xfrm>
+          <a:prstGeom prst="rect">
+            <a:avLst/>
+          </a:prstGeom>
+          <a:noFill/>
+          <a:ln/>
+        </p:spPr>
+        <p:txBody>
+          <a:bodyPr wrap="square" lIns="0" tIns="0" rIns="0" bIns="0" rtlCol="0" anchor="t"/>
           <a:lstStyle/>
           <a:p>
             <a:pPr indent="0" marL="0">
@@ -4940,6 +5096,54 @@
               <a:t>of the world’s long-span bridges carry any monitoring hardware at all</a:t>
             </a:r>
             <a:endParaRPr lang="en-US" sz="1400" dirty="0"/>
+          </a:p>
+        </p:txBody>
+      </p:sp>
+      <p:sp>
+        <p:nvSpPr>
+          <p:cNvPr id="25" name="Slide Number Placeholder 0"/>
+          <p:cNvSpPr>
+            <a:spLocks noGrp="1"/>
+          </p:cNvSpPr>
+          <p:nvPr>
+            <p:ph type="sldNum" sz="quarter" idx="4294967295"/>
+          </p:nvPr>
+        </p:nvSpPr>
+        <p:spPr>
+          <a:xfrm>
+            <a:off x="11622024" y="6510528"/>
+            <a:ext cx="800000" cy="300000"/>
+          </a:xfrm>
+          <a:prstGeom prst="rect">
+            <a:avLst/>
+          </a:prstGeom>
+          <a:extLst>
+            <a:ext uri="{C572A759-6A51-4108-AA02-DFA0A04FC94B}">
+              <ma14:wrappingTextBoxFlag xmlns:ma14="http://schemas.microsoft.com/office/mac/drawingml/2011/main" val="0"/>
+            </a:ext>
+          </a:extLst>
+        </p:spPr>
+        <p:txBody>
+          <a:bodyPr/>
+          <a:lstStyle>
+            <a:lvl1pPr>
+              <a:defRPr sz="900">
+                <a:solidFill>
+                  <a:srgbClr val="5C6795"/>
+                </a:solidFill>
+                <a:latin typeface="Courier New"/>
+                <a:ea typeface="Courier New"/>
+                <a:cs typeface="Courier New"/>
+              </a:defRPr>
+            </a:lvl1pPr>
+          </a:lstStyle>
+          <a:p>
+            <a:pPr algn="l"/>
+            <a:fld id="{F7021451-1387-4CA6-816F-3879F97B5CBC}" type="slidenum">
+              <a:rPr b="0" lang="en-US"/>
+              <a:t>2</a:t>
+            </a:fld>
+            <a:endParaRPr lang="en-US"/>
           </a:p>
         </p:txBody>
       </p:sp>
@@ -4993,10 +5197,10 @@
           <a:ln/>
         </p:spPr>
         <p:txBody>
-          <a:bodyPr wrap="square" lIns="0" tIns="0" rIns="0" bIns="0" rtlCol="0" anchor="ctr"/>
-          <a:lstStyle/>
-          <a:p>
-            <a:pPr indent="0" marL="0">
+          <a:bodyPr wrap="square" lIns="0" tIns="0" rIns="0" bIns="0" rtlCol="0" anchor="t"/>
+          <a:lstStyle/>
+          <a:p>
+            <a:pPr algn="l" indent="0" marL="0">
               <a:buNone/>
             </a:pPr>
             <a:r>
@@ -5092,7 +5296,7 @@
                 <a:ea typeface="Calibri" pitchFamily="34" charset="-122"/>
                 <a:cs typeface="Calibri" pitchFamily="34" charset="-120"/>
               </a:rPr>
-              <a:t>Eight documented failures across three continents. In each one the evidence was on file, in time to act, and belonged to nobody.</a:t>
+              <a:t>Six of the eight documented failures we studied, across three continents. In each one the evidence was on file, in time to act, and belonged to nobody.</a:t>
             </a:r>
             <a:endParaRPr lang="en-US" sz="1450" dirty="0"/>
           </a:p>
@@ -5107,7 +5311,7 @@
         <p:spPr>
           <a:xfrm>
             <a:off x="594360" y="2240280"/>
-            <a:ext cx="3456432" cy="1874520"/>
+            <a:ext cx="3383280" cy="1874520"/>
           </a:xfrm>
           <a:prstGeom prst="rect">
             <a:avLst/>
@@ -5209,27 +5413,27 @@
         </p:nvSpPr>
         <p:spPr>
           <a:xfrm>
-            <a:off x="777240" y="2971800"/>
-            <a:ext cx="3108960" cy="1005840"/>
-          </a:xfrm>
-          <a:prstGeom prst="rect">
-            <a:avLst/>
-          </a:prstGeom>
-          <a:noFill/>
-          <a:ln/>
-        </p:spPr>
-        <p:txBody>
-          <a:bodyPr wrap="square" lIns="0" tIns="0" rIns="0" bIns="0" rtlCol="0" anchor="ctr"/>
+            <a:off x="777240" y="2953512"/>
+            <a:ext cx="3035808" cy="1078992"/>
+          </a:xfrm>
+          <a:prstGeom prst="rect">
+            <a:avLst/>
+          </a:prstGeom>
+          <a:noFill/>
+          <a:ln/>
+        </p:spPr>
+        <p:txBody>
+          <a:bodyPr wrap="square" lIns="0" tIns="0" rIns="0" bIns="0" rtlCol="0" anchor="t"/>
           <a:lstStyle/>
           <a:p>
             <a:pPr indent="0" marL="0">
               <a:lnSpc>
-                <a:spcPts val="1350"/>
+                <a:spcPts val="1250"/>
               </a:lnSpc>
               <a:buNone/>
             </a:pPr>
             <a:r>
-              <a:rPr lang="en-US" sz="1000" dirty="0">
+              <a:rPr lang="en-US" sz="950" dirty="0">
                 <a:solidFill>
                   <a:srgbClr val="20263E"/>
                 </a:solidFill>
@@ -5237,9 +5441,9 @@
                 <a:ea typeface="Calibri" pitchFamily="34" charset="-122"/>
                 <a:cs typeface="Calibri" pitchFamily="34" charset="-120"/>
               </a:rPr>
-              <a:t>A satellite radar scatterer on the deck beside the failed pier accelerated from about 10 to 70 mm/yr starting March 2017, seventeen months before collapse (Milillo e…</a:t>
-            </a:r>
-            <a:endParaRPr lang="en-US" sz="1000" dirty="0"/>
+              <a:t>A satellite radar scatterer on the deck beside the failed pier accelerated from about 10 to 70 mm/yr starting March 2017, seventeen months before collapse (Milillo et al. 2019; contested by Lanari et al. 2020).</a:t>
+            </a:r>
+            <a:endParaRPr lang="en-US" sz="950" dirty="0"/>
           </a:p>
         </p:txBody>
       </p:sp>
@@ -5251,8 +5455,8 @@
         </p:nvSpPr>
         <p:spPr>
           <a:xfrm>
-            <a:off x="4279392" y="2240280"/>
-            <a:ext cx="3456432" cy="1874520"/>
+            <a:off x="4251960" y="2240280"/>
+            <a:ext cx="3383280" cy="1874520"/>
           </a:xfrm>
           <a:prstGeom prst="rect">
             <a:avLst/>
@@ -5276,7 +5480,7 @@
         </p:nvSpPr>
         <p:spPr>
           <a:xfrm>
-            <a:off x="4462272" y="2386584"/>
+            <a:off x="4434840" y="2386584"/>
             <a:ext cx="3108960" cy="292608"/>
           </a:xfrm>
           <a:prstGeom prst="rect">
@@ -5315,7 +5519,7 @@
         </p:nvSpPr>
         <p:spPr>
           <a:xfrm>
-            <a:off x="4462272" y="2715768"/>
+            <a:off x="4434840" y="2715768"/>
             <a:ext cx="3108960" cy="201168"/>
           </a:xfrm>
           <a:prstGeom prst="rect">
@@ -5354,27 +5558,27 @@
         </p:nvSpPr>
         <p:spPr>
           <a:xfrm>
-            <a:off x="4462272" y="2971800"/>
-            <a:ext cx="3108960" cy="1005840"/>
-          </a:xfrm>
-          <a:prstGeom prst="rect">
-            <a:avLst/>
-          </a:prstGeom>
-          <a:noFill/>
-          <a:ln/>
-        </p:spPr>
-        <p:txBody>
-          <a:bodyPr wrap="square" lIns="0" tIns="0" rIns="0" bIns="0" rtlCol="0" anchor="ctr"/>
+            <a:off x="4434840" y="2953512"/>
+            <a:ext cx="3035808" cy="1078992"/>
+          </a:xfrm>
+          <a:prstGeom prst="rect">
+            <a:avLst/>
+          </a:prstGeom>
+          <a:noFill/>
+          <a:ln/>
+        </p:spPr>
+        <p:txBody>
+          <a:bodyPr wrap="square" lIns="0" tIns="0" rIns="0" bIns="0" rtlCol="0" anchor="t"/>
           <a:lstStyle/>
           <a:p>
             <a:pPr indent="0" marL="0">
               <a:lnSpc>
-                <a:spcPts val="1350"/>
+                <a:spcPts val="1250"/>
               </a:lnSpc>
               <a:buNone/>
             </a:pPr>
             <a:r>
-              <a:rPr lang="en-US" sz="1000" dirty="0">
+              <a:rPr lang="en-US" sz="950" dirty="0">
                 <a:solidFill>
                   <a:srgbClr val="20263E"/>
                 </a:solidFill>
@@ -5384,7 +5588,7 @@
               </a:rPr>
               <a:t>Inspection photographs from 1999 and 2003 already showed visibly bowed gusset plates (NTSB HAR-08/03).</a:t>
             </a:r>
-            <a:endParaRPr lang="en-US" sz="1000" dirty="0"/>
+            <a:endParaRPr lang="en-US" sz="950" dirty="0"/>
           </a:p>
         </p:txBody>
       </p:sp>
@@ -5396,8 +5600,8 @@
         </p:nvSpPr>
         <p:spPr>
           <a:xfrm>
-            <a:off x="7964424" y="2240280"/>
-            <a:ext cx="3456432" cy="1874520"/>
+            <a:off x="7909560" y="2240280"/>
+            <a:ext cx="3383280" cy="1874520"/>
           </a:xfrm>
           <a:prstGeom prst="rect">
             <a:avLst/>
@@ -5421,7 +5625,7 @@
         </p:nvSpPr>
         <p:spPr>
           <a:xfrm>
-            <a:off x="8147304" y="2386584"/>
+            <a:off x="8092440" y="2386584"/>
             <a:ext cx="3108960" cy="292608"/>
           </a:xfrm>
           <a:prstGeom prst="rect">
@@ -5460,7 +5664,7 @@
         </p:nvSpPr>
         <p:spPr>
           <a:xfrm>
-            <a:off x="8147304" y="2715768"/>
+            <a:off x="8092440" y="2715768"/>
             <a:ext cx="3108960" cy="201168"/>
           </a:xfrm>
           <a:prstGeom prst="rect">
@@ -5499,27 +5703,27 @@
         </p:nvSpPr>
         <p:spPr>
           <a:xfrm>
-            <a:off x="8147304" y="2971800"/>
-            <a:ext cx="3108960" cy="1005840"/>
-          </a:xfrm>
-          <a:prstGeom prst="rect">
-            <a:avLst/>
-          </a:prstGeom>
-          <a:noFill/>
-          <a:ln/>
-        </p:spPr>
-        <p:txBody>
-          <a:bodyPr wrap="square" lIns="0" tIns="0" rIns="0" bIns="0" rtlCol="0" anchor="ctr"/>
+            <a:off x="8092440" y="2953512"/>
+            <a:ext cx="3035808" cy="1078992"/>
+          </a:xfrm>
+          <a:prstGeom prst="rect">
+            <a:avLst/>
+          </a:prstGeom>
+          <a:noFill/>
+          <a:ln/>
+        </p:spPr>
+        <p:txBody>
+          <a:bodyPr wrap="square" lIns="0" tIns="0" rIns="0" bIns="0" rtlCol="0" anchor="t"/>
           <a:lstStyle/>
           <a:p>
             <a:pPr indent="0" marL="0">
               <a:lnSpc>
-                <a:spcPts val="1350"/>
+                <a:spcPts val="1250"/>
               </a:lnSpc>
               <a:buNone/>
             </a:pPr>
             <a:r>
-              <a:rPr lang="en-US" sz="1000" dirty="0">
+              <a:rPr lang="en-US" sz="950" dirty="0">
                 <a:solidFill>
                   <a:srgbClr val="20263E"/>
                 </a:solidFill>
@@ -5529,7 +5733,7 @@
               </a:rPr>
               <a:t>Rapidly growing structural cracks, photographed and discussed by the engineer of record in the days before failure.</a:t>
             </a:r>
-            <a:endParaRPr lang="en-US" sz="1000" dirty="0"/>
+            <a:endParaRPr lang="en-US" sz="950" dirty="0"/>
           </a:p>
         </p:txBody>
       </p:sp>
@@ -5542,7 +5746,7 @@
         <p:spPr>
           <a:xfrm>
             <a:off x="594360" y="4297680"/>
-            <a:ext cx="3456432" cy="1874520"/>
+            <a:ext cx="3383280" cy="1874520"/>
           </a:xfrm>
           <a:prstGeom prst="rect">
             <a:avLst/>
@@ -5644,27 +5848,27 @@
         </p:nvSpPr>
         <p:spPr>
           <a:xfrm>
-            <a:off x="777240" y="5029200"/>
-            <a:ext cx="3108960" cy="1005840"/>
-          </a:xfrm>
-          <a:prstGeom prst="rect">
-            <a:avLst/>
-          </a:prstGeom>
-          <a:noFill/>
-          <a:ln/>
-        </p:spPr>
-        <p:txBody>
-          <a:bodyPr wrap="square" lIns="0" tIns="0" rIns="0" bIns="0" rtlCol="0" anchor="ctr"/>
+            <a:off x="777240" y="5010912"/>
+            <a:ext cx="3035808" cy="1078992"/>
+          </a:xfrm>
+          <a:prstGeom prst="rect">
+            <a:avLst/>
+          </a:prstGeom>
+          <a:noFill/>
+          <a:ln/>
+        </p:spPr>
+        <p:txBody>
+          <a:bodyPr wrap="square" lIns="0" tIns="0" rIns="0" bIns="0" rtlCol="0" anchor="t"/>
           <a:lstStyle/>
           <a:p>
             <a:pPr indent="0" marL="0">
               <a:lnSpc>
-                <a:spcPts val="1350"/>
+                <a:spcPts val="1250"/>
               </a:lnSpc>
               <a:buNone/>
             </a:pPr>
             <a:r>
-              <a:rPr lang="en-US" sz="1000" dirty="0">
+              <a:rPr lang="en-US" sz="950" dirty="0">
                 <a:solidFill>
                   <a:srgbClr val="20263E"/>
                 </a:solidFill>
@@ -5672,9 +5876,9 @@
                 <a:ea typeface="Calibri" pitchFamily="34" charset="-122"/>
                 <a:cs typeface="Calibri" pitchFamily="34" charset="-120"/>
               </a:rPr>
-              <a:t>A satellite study published in 2020 had identified the site subsiding by about 2 mm/yr in the 1990s (Fiaschi and Wdowinski); a 2018 engineering report documented maj…</a:t>
-            </a:r>
-            <a:endParaRPr lang="en-US" sz="1000" dirty="0"/>
+              <a:t>A satellite study published in 2020 had identified the site subsiding by about 2 mm/yr in the 1990s (Fiaschi and Wdowinski); a 2018 engineering report documented major structural damage.</a:t>
+            </a:r>
+            <a:endParaRPr lang="en-US" sz="950" dirty="0"/>
           </a:p>
         </p:txBody>
       </p:sp>
@@ -5686,8 +5890,8 @@
         </p:nvSpPr>
         <p:spPr>
           <a:xfrm>
-            <a:off x="4279392" y="4297680"/>
-            <a:ext cx="3456432" cy="1874520"/>
+            <a:off x="4251960" y="4297680"/>
+            <a:ext cx="3383280" cy="1874520"/>
           </a:xfrm>
           <a:prstGeom prst="rect">
             <a:avLst/>
@@ -5711,7 +5915,7 @@
         </p:nvSpPr>
         <p:spPr>
           <a:xfrm>
-            <a:off x="4462272" y="4443984"/>
+            <a:off x="4434840" y="4443984"/>
             <a:ext cx="3108960" cy="292608"/>
           </a:xfrm>
           <a:prstGeom prst="rect">
@@ -5750,7 +5954,7 @@
         </p:nvSpPr>
         <p:spPr>
           <a:xfrm>
-            <a:off x="4462272" y="4773168"/>
+            <a:off x="4434840" y="4773168"/>
             <a:ext cx="3108960" cy="201168"/>
           </a:xfrm>
           <a:prstGeom prst="rect">
@@ -5789,27 +5993,27 @@
         </p:nvSpPr>
         <p:spPr>
           <a:xfrm>
-            <a:off x="4462272" y="5029200"/>
-            <a:ext cx="3108960" cy="1005840"/>
-          </a:xfrm>
-          <a:prstGeom prst="rect">
-            <a:avLst/>
-          </a:prstGeom>
-          <a:noFill/>
-          <a:ln/>
-        </p:spPr>
-        <p:txBody>
-          <a:bodyPr wrap="square" lIns="0" tIns="0" rIns="0" bIns="0" rtlCol="0" anchor="ctr"/>
+            <a:off x="4434840" y="5010912"/>
+            <a:ext cx="3035808" cy="1078992"/>
+          </a:xfrm>
+          <a:prstGeom prst="rect">
+            <a:avLst/>
+          </a:prstGeom>
+          <a:noFill/>
+          <a:ln/>
+        </p:spPr>
+        <p:txBody>
+          <a:bodyPr wrap="square" lIns="0" tIns="0" rIns="0" bIns="0" rtlCol="0" anchor="t"/>
           <a:lstStyle/>
           <a:p>
             <a:pPr indent="0" marL="0">
               <a:lnSpc>
-                <a:spcPts val="1350"/>
+                <a:spcPts val="1250"/>
               </a:lnSpc>
               <a:buNone/>
             </a:pPr>
             <a:r>
-              <a:rPr lang="en-US" sz="1000" dirty="0">
+              <a:rPr lang="en-US" sz="950" dirty="0">
                 <a:solidFill>
                   <a:srgbClr val="20263E"/>
                 </a:solidFill>
@@ -5817,9 +6021,9 @@
                 <a:ea typeface="Calibri" pitchFamily="34" charset="-122"/>
                 <a:cs typeface="Calibri" pitchFamily="34" charset="-120"/>
               </a:rPr>
-              <a:t>Reopened four days after a renovation that never replaced or load-tested the original main cables; the inquiry later found 22 of the 49 wires in the failed cable alr…</a:t>
-            </a:r>
-            <a:endParaRPr lang="en-US" sz="1000" dirty="0"/>
+              <a:t>Reopened four days after a renovation that never replaced or load-tested the original main cables; the inquiry later found 22 of the 49 wires in the failed cable already corroded.</a:t>
+            </a:r>
+            <a:endParaRPr lang="en-US" sz="950" dirty="0"/>
           </a:p>
         </p:txBody>
       </p:sp>
@@ -5831,8 +6035,8 @@
         </p:nvSpPr>
         <p:spPr>
           <a:xfrm>
-            <a:off x="7964424" y="4297680"/>
-            <a:ext cx="3456432" cy="1874520"/>
+            <a:off x="7909560" y="4297680"/>
+            <a:ext cx="3383280" cy="1874520"/>
           </a:xfrm>
           <a:prstGeom prst="rect">
             <a:avLst/>
@@ -5856,7 +6060,7 @@
         </p:nvSpPr>
         <p:spPr>
           <a:xfrm>
-            <a:off x="8147304" y="4443984"/>
+            <a:off x="8092440" y="4443984"/>
             <a:ext cx="3108960" cy="292608"/>
           </a:xfrm>
           <a:prstGeom prst="rect">
@@ -5895,7 +6099,7 @@
         </p:nvSpPr>
         <p:spPr>
           <a:xfrm>
-            <a:off x="8147304" y="4773168"/>
+            <a:off x="8092440" y="4773168"/>
             <a:ext cx="3108960" cy="201168"/>
           </a:xfrm>
           <a:prstGeom prst="rect">
@@ -5920,7 +6124,7 @@
                 <a:ea typeface="Courier New" pitchFamily="34" charset="-122"/>
                 <a:cs typeface="Courier New" pitchFamily="34" charset="-120"/>
               </a:rPr>
-              <a:t>DRESDEN, GERMANY  ·  11 SEP 2024</a:t>
+              <a:t>DRESDEN, GERMANY  ·  11 SEP 2024  ·  0 DEAD</a:t>
             </a:r>
             <a:endParaRPr lang="en-US" sz="800" dirty="0"/>
           </a:p>
@@ -5934,27 +6138,27 @@
         </p:nvSpPr>
         <p:spPr>
           <a:xfrm>
-            <a:off x="8147304" y="5029200"/>
-            <a:ext cx="3108960" cy="1005840"/>
-          </a:xfrm>
-          <a:prstGeom prst="rect">
-            <a:avLst/>
-          </a:prstGeom>
-          <a:noFill/>
-          <a:ln/>
-        </p:spPr>
-        <p:txBody>
-          <a:bodyPr wrap="square" lIns="0" tIns="0" rIns="0" bIns="0" rtlCol="0" anchor="ctr"/>
+            <a:off x="8092440" y="5010912"/>
+            <a:ext cx="3035808" cy="1078992"/>
+          </a:xfrm>
+          <a:prstGeom prst="rect">
+            <a:avLst/>
+          </a:prstGeom>
+          <a:noFill/>
+          <a:ln/>
+        </p:spPr>
+        <p:txBody>
+          <a:bodyPr wrap="square" lIns="0" tIns="0" rIns="0" bIns="0" rtlCol="0" anchor="t"/>
           <a:lstStyle/>
           <a:p>
             <a:pPr indent="0" marL="0">
               <a:lnSpc>
-                <a:spcPts val="1350"/>
+                <a:spcPts val="1250"/>
               </a:lnSpc>
               <a:buNone/>
             </a:pPr>
             <a:r>
-              <a:rPr lang="en-US" sz="1000" dirty="0">
+              <a:rPr lang="en-US" sz="950" dirty="0">
                 <a:solidFill>
                   <a:srgbClr val="20263E"/>
                 </a:solidFill>
@@ -5964,7 +6168,55 @@
               </a:rPr>
               <a:t>Hidden hydrogen-induced corrosion of the prestressing steel, progressing for decades inside the one deck not yet refurbished (Marx report, TU Dresden).</a:t>
             </a:r>
-            <a:endParaRPr lang="en-US" sz="1000" dirty="0"/>
+            <a:endParaRPr lang="en-US" sz="950" dirty="0"/>
+          </a:p>
+        </p:txBody>
+      </p:sp>
+      <p:sp>
+        <p:nvSpPr>
+          <p:cNvPr id="25" name="Slide Number Placeholder 0"/>
+          <p:cNvSpPr>
+            <a:spLocks noGrp="1"/>
+          </p:cNvSpPr>
+          <p:nvPr>
+            <p:ph type="sldNum" sz="quarter" idx="4294967295"/>
+          </p:nvPr>
+        </p:nvSpPr>
+        <p:spPr>
+          <a:xfrm>
+            <a:off x="11622024" y="6510528"/>
+            <a:ext cx="800000" cy="300000"/>
+          </a:xfrm>
+          <a:prstGeom prst="rect">
+            <a:avLst/>
+          </a:prstGeom>
+          <a:extLst>
+            <a:ext uri="{C572A759-6A51-4108-AA02-DFA0A04FC94B}">
+              <ma14:wrappingTextBoxFlag xmlns:ma14="http://schemas.microsoft.com/office/mac/drawingml/2011/main" val="0"/>
+            </a:ext>
+          </a:extLst>
+        </p:spPr>
+        <p:txBody>
+          <a:bodyPr/>
+          <a:lstStyle>
+            <a:lvl1pPr>
+              <a:defRPr sz="900">
+                <a:solidFill>
+                  <a:srgbClr val="B3AC9A"/>
+                </a:solidFill>
+                <a:latin typeface="Courier New"/>
+                <a:ea typeface="Courier New"/>
+                <a:cs typeface="Courier New"/>
+              </a:defRPr>
+            </a:lvl1pPr>
+          </a:lstStyle>
+          <a:p>
+            <a:pPr algn="l"/>
+            <a:fld id="{F7021451-1387-4CA6-816F-3879F97B5CBC}" type="slidenum">
+              <a:rPr b="0" lang="en-US"/>
+              <a:t>3</a:t>
+            </a:fld>
+            <a:endParaRPr lang="en-US"/>
           </a:p>
         </p:txBody>
       </p:sp>
@@ -6018,16 +6270,16 @@
           <a:ln/>
         </p:spPr>
         <p:txBody>
-          <a:bodyPr wrap="square" lIns="0" tIns="0" rIns="0" bIns="0" rtlCol="0" anchor="ctr"/>
-          <a:lstStyle/>
-          <a:p>
-            <a:pPr indent="0" marL="0">
+          <a:bodyPr wrap="square" lIns="0" tIns="0" rIns="0" bIns="0" rtlCol="0" anchor="t"/>
+          <a:lstStyle/>
+          <a:p>
+            <a:pPr algn="l" indent="0" marL="0">
               <a:buNone/>
             </a:pPr>
             <a:r>
               <a:rPr lang="en-US" sz="1050" spc="120" kern="0" dirty="0">
                 <a:solidFill>
-                  <a:srgbClr val="C6283C"/>
+                  <a:srgbClr val="E4607A"/>
                 </a:solidFill>
                 <a:latin typeface="Courier New" pitchFamily="34" charset="0"/>
                 <a:ea typeface="Courier New" pitchFamily="34" charset="-122"/>
@@ -6274,17 +6526,17 @@
         </p:nvSpPr>
         <p:spPr>
           <a:xfrm>
-            <a:off x="758952" y="3913632"/>
-            <a:ext cx="4846320" cy="1005840"/>
-          </a:xfrm>
-          <a:prstGeom prst="rect">
-            <a:avLst/>
-          </a:prstGeom>
-          <a:noFill/>
-          <a:ln/>
-        </p:spPr>
-        <p:txBody>
-          <a:bodyPr wrap="square" lIns="0" tIns="0" rIns="0" bIns="0" rtlCol="0" anchor="ctr"/>
+            <a:off x="758952" y="3840480"/>
+            <a:ext cx="4846320" cy="1051560"/>
+          </a:xfrm>
+          <a:prstGeom prst="rect">
+            <a:avLst/>
+          </a:prstGeom>
+          <a:noFill/>
+          <a:ln/>
+        </p:spPr>
+        <p:txBody>
+          <a:bodyPr wrap="square" lIns="0" tIns="0" rIns="0" bIns="0" rtlCol="0" anchor="t"/>
           <a:lstStyle/>
           <a:p>
             <a:pPr indent="0" marL="0">
@@ -6302,7 +6554,7 @@
                 <a:ea typeface="Calibri" pitchFamily="34" charset="-122"/>
                 <a:cs typeface="Calibri" pitchFamily="34" charset="-120"/>
               </a:rPr>
-              <a:t>Condition ratings 0–9, thirty-four years of filings, maintenance and construction history — every human judgement quarantined here.</a:t>
+              <a:t>Condition ratings 0–9, thirty-four years of filings, maintenance and construction history. Every human judgement is quarantined here.</a:t>
             </a:r>
             <a:endParaRPr lang="en-US" sz="1150" dirty="0"/>
           </a:p>
@@ -6439,17 +6691,17 @@
         </p:nvSpPr>
         <p:spPr>
           <a:xfrm>
-            <a:off x="6291072" y="3913632"/>
-            <a:ext cx="4846320" cy="1005840"/>
-          </a:xfrm>
-          <a:prstGeom prst="rect">
-            <a:avLst/>
-          </a:prstGeom>
-          <a:noFill/>
-          <a:ln/>
-        </p:spPr>
-        <p:txBody>
-          <a:bodyPr wrap="square" lIns="0" tIns="0" rIns="0" bIns="0" rtlCol="0" anchor="ctr"/>
+            <a:off x="6291072" y="3840480"/>
+            <a:ext cx="4846320" cy="1051560"/>
+          </a:xfrm>
+          <a:prstGeom prst="rect">
+            <a:avLst/>
+          </a:prstGeom>
+          <a:noFill/>
+          <a:ln/>
+        </p:spPr>
+        <p:txBody>
+          <a:bodyPr wrap="square" lIns="0" tIns="0" rIns="0" bIns="0" rtlCol="0" anchor="t"/>
           <a:lstStyle/>
           <a:p>
             <a:pPr indent="0" marL="0">
@@ -6509,6 +6761,54 @@
               <a:t>When the two stop agreeing, the machine files a dissent: a dated obligation with the evidence attached.</a:t>
             </a:r>
             <a:endParaRPr lang="en-US" sz="1600" dirty="0"/>
+          </a:p>
+        </p:txBody>
+      </p:sp>
+      <p:sp>
+        <p:nvSpPr>
+          <p:cNvPr id="25" name="Slide Number Placeholder 0"/>
+          <p:cNvSpPr>
+            <a:spLocks noGrp="1"/>
+          </p:cNvSpPr>
+          <p:nvPr>
+            <p:ph type="sldNum" sz="quarter" idx="4294967295"/>
+          </p:nvPr>
+        </p:nvSpPr>
+        <p:spPr>
+          <a:xfrm>
+            <a:off x="11622024" y="6510528"/>
+            <a:ext cx="800000" cy="300000"/>
+          </a:xfrm>
+          <a:prstGeom prst="rect">
+            <a:avLst/>
+          </a:prstGeom>
+          <a:extLst>
+            <a:ext uri="{C572A759-6A51-4108-AA02-DFA0A04FC94B}">
+              <ma14:wrappingTextBoxFlag xmlns:ma14="http://schemas.microsoft.com/office/mac/drawingml/2011/main" val="0"/>
+            </a:ext>
+          </a:extLst>
+        </p:spPr>
+        <p:txBody>
+          <a:bodyPr/>
+          <a:lstStyle>
+            <a:lvl1pPr>
+              <a:defRPr sz="900">
+                <a:solidFill>
+                  <a:srgbClr val="5C6795"/>
+                </a:solidFill>
+                <a:latin typeface="Courier New"/>
+                <a:ea typeface="Courier New"/>
+                <a:cs typeface="Courier New"/>
+              </a:defRPr>
+            </a:lvl1pPr>
+          </a:lstStyle>
+          <a:p>
+            <a:pPr algn="l"/>
+            <a:fld id="{F7021451-1387-4CA6-816F-3879F97B5CBC}" type="slidenum">
+              <a:rPr b="0" lang="en-US"/>
+              <a:t>4</a:t>
+            </a:fld>
+            <a:endParaRPr lang="en-US"/>
           </a:p>
         </p:txBody>
       </p:sp>
@@ -6562,10 +6862,10 @@
           <a:ln/>
         </p:spPr>
         <p:txBody>
-          <a:bodyPr wrap="square" lIns="0" tIns="0" rIns="0" bIns="0" rtlCol="0" anchor="ctr"/>
-          <a:lstStyle/>
-          <a:p>
-            <a:pPr indent="0" marL="0">
+          <a:bodyPr wrap="square" lIns="0" tIns="0" rIns="0" bIns="0" rtlCol="0" anchor="t"/>
+          <a:lstStyle/>
+          <a:p>
+            <a:pPr algn="l" indent="0" marL="0">
               <a:buNone/>
             </a:pPr>
             <a:r>
@@ -6652,7 +6952,7 @@
             <a:r>
               <a:rPr lang="en-US" sz="3000" b="1" dirty="0">
                 <a:solidFill>
-                  <a:srgbClr val="E4E0D3"/>
+                  <a:srgbClr val="C2BAA6"/>
                 </a:solidFill>
                 <a:latin typeface="Cambria" pitchFamily="34" charset="0"/>
                 <a:ea typeface="Cambria" pitchFamily="34" charset="-122"/>
@@ -6711,17 +7011,17 @@
         </p:nvSpPr>
         <p:spPr>
           <a:xfrm>
-            <a:off x="1325880" y="1984248"/>
-            <a:ext cx="4480560" cy="960120"/>
-          </a:xfrm>
-          <a:prstGeom prst="rect">
-            <a:avLst/>
-          </a:prstGeom>
-          <a:noFill/>
-          <a:ln/>
-        </p:spPr>
-        <p:txBody>
-          <a:bodyPr wrap="square" lIns="0" tIns="0" rIns="0" bIns="0" rtlCol="0" anchor="ctr"/>
+            <a:off x="1325880" y="1965960"/>
+            <a:ext cx="4480560" cy="1005840"/>
+          </a:xfrm>
+          <a:prstGeom prst="rect">
+            <a:avLst/>
+          </a:prstGeom>
+          <a:noFill/>
+          <a:ln/>
+        </p:spPr>
+        <p:txBody>
+          <a:bodyPr wrap="square" lIns="0" tIns="0" rIns="0" bIns="0" rtlCol="0" anchor="t"/>
           <a:lstStyle/>
           <a:p>
             <a:pPr indent="0" marL="0">
@@ -6772,7 +7072,7 @@
             <a:r>
               <a:rPr lang="en-US" sz="3000" b="1" dirty="0">
                 <a:solidFill>
-                  <a:srgbClr val="E4E0D3"/>
+                  <a:srgbClr val="C2BAA6"/>
                 </a:solidFill>
                 <a:latin typeface="Cambria" pitchFamily="34" charset="0"/>
                 <a:ea typeface="Cambria" pitchFamily="34" charset="-122"/>
@@ -6831,17 +7131,17 @@
         </p:nvSpPr>
         <p:spPr>
           <a:xfrm>
-            <a:off x="6858000" y="1984248"/>
-            <a:ext cx="4480560" cy="960120"/>
-          </a:xfrm>
-          <a:prstGeom prst="rect">
-            <a:avLst/>
-          </a:prstGeom>
-          <a:noFill/>
-          <a:ln/>
-        </p:spPr>
-        <p:txBody>
-          <a:bodyPr wrap="square" lIns="0" tIns="0" rIns="0" bIns="0" rtlCol="0" anchor="ctr"/>
+            <a:off x="6858000" y="1965960"/>
+            <a:ext cx="4480560" cy="1005840"/>
+          </a:xfrm>
+          <a:prstGeom prst="rect">
+            <a:avLst/>
+          </a:prstGeom>
+          <a:noFill/>
+          <a:ln/>
+        </p:spPr>
+        <p:txBody>
+          <a:bodyPr wrap="square" lIns="0" tIns="0" rIns="0" bIns="0" rtlCol="0" anchor="t"/>
           <a:lstStyle/>
           <a:p>
             <a:pPr indent="0" marL="0">
@@ -6892,7 +7192,7 @@
             <a:r>
               <a:rPr lang="en-US" sz="3000" b="1" dirty="0">
                 <a:solidFill>
-                  <a:srgbClr val="E4E0D3"/>
+                  <a:srgbClr val="C2BAA6"/>
                 </a:solidFill>
                 <a:latin typeface="Cambria" pitchFamily="34" charset="0"/>
                 <a:ea typeface="Cambria" pitchFamily="34" charset="-122"/>
@@ -6951,17 +7251,17 @@
         </p:nvSpPr>
         <p:spPr>
           <a:xfrm>
-            <a:off x="1325880" y="3557016"/>
-            <a:ext cx="4480560" cy="960120"/>
-          </a:xfrm>
-          <a:prstGeom prst="rect">
-            <a:avLst/>
-          </a:prstGeom>
-          <a:noFill/>
-          <a:ln/>
-        </p:spPr>
-        <p:txBody>
-          <a:bodyPr wrap="square" lIns="0" tIns="0" rIns="0" bIns="0" rtlCol="0" anchor="ctr"/>
+            <a:off x="1325880" y="3538728"/>
+            <a:ext cx="4480560" cy="1005840"/>
+          </a:xfrm>
+          <a:prstGeom prst="rect">
+            <a:avLst/>
+          </a:prstGeom>
+          <a:noFill/>
+          <a:ln/>
+        </p:spPr>
+        <p:txBody>
+          <a:bodyPr wrap="square" lIns="0" tIns="0" rIns="0" bIns="0" rtlCol="0" anchor="t"/>
           <a:lstStyle/>
           <a:p>
             <a:pPr indent="0" marL="0">
@@ -7012,7 +7312,7 @@
             <a:r>
               <a:rPr lang="en-US" sz="3000" b="1" dirty="0">
                 <a:solidFill>
-                  <a:srgbClr val="E4E0D3"/>
+                  <a:srgbClr val="C2BAA6"/>
                 </a:solidFill>
                 <a:latin typeface="Cambria" pitchFamily="34" charset="0"/>
                 <a:ea typeface="Cambria" pitchFamily="34" charset="-122"/>
@@ -7071,17 +7371,17 @@
         </p:nvSpPr>
         <p:spPr>
           <a:xfrm>
-            <a:off x="6858000" y="3557016"/>
-            <a:ext cx="4480560" cy="960120"/>
-          </a:xfrm>
-          <a:prstGeom prst="rect">
-            <a:avLst/>
-          </a:prstGeom>
-          <a:noFill/>
-          <a:ln/>
-        </p:spPr>
-        <p:txBody>
-          <a:bodyPr wrap="square" lIns="0" tIns="0" rIns="0" bIns="0" rtlCol="0" anchor="ctr"/>
+            <a:off x="6858000" y="3538728"/>
+            <a:ext cx="4480560" cy="1005840"/>
+          </a:xfrm>
+          <a:prstGeom prst="rect">
+            <a:avLst/>
+          </a:prstGeom>
+          <a:noFill/>
+          <a:ln/>
+        </p:spPr>
+        <p:txBody>
+          <a:bodyPr wrap="square" lIns="0" tIns="0" rIns="0" bIns="0" rtlCol="0" anchor="t"/>
           <a:lstStyle/>
           <a:p>
             <a:pPr indent="0" marL="0">
@@ -7132,7 +7432,7 @@
             <a:r>
               <a:rPr lang="en-US" sz="3000" b="1" dirty="0">
                 <a:solidFill>
-                  <a:srgbClr val="E4E0D3"/>
+                  <a:srgbClr val="C2BAA6"/>
                 </a:solidFill>
                 <a:latin typeface="Cambria" pitchFamily="34" charset="0"/>
                 <a:ea typeface="Cambria" pitchFamily="34" charset="-122"/>
@@ -7191,17 +7491,17 @@
         </p:nvSpPr>
         <p:spPr>
           <a:xfrm>
-            <a:off x="1325880" y="5129784"/>
-            <a:ext cx="4480560" cy="960120"/>
-          </a:xfrm>
-          <a:prstGeom prst="rect">
-            <a:avLst/>
-          </a:prstGeom>
-          <a:noFill/>
-          <a:ln/>
-        </p:spPr>
-        <p:txBody>
-          <a:bodyPr wrap="square" lIns="0" tIns="0" rIns="0" bIns="0" rtlCol="0" anchor="ctr"/>
+            <a:off x="1325880" y="5111496"/>
+            <a:ext cx="4480560" cy="1005840"/>
+          </a:xfrm>
+          <a:prstGeom prst="rect">
+            <a:avLst/>
+          </a:prstGeom>
+          <a:noFill/>
+          <a:ln/>
+        </p:spPr>
+        <p:txBody>
+          <a:bodyPr wrap="square" lIns="0" tIns="0" rIns="0" bIns="0" rtlCol="0" anchor="t"/>
           <a:lstStyle/>
           <a:p>
             <a:pPr indent="0" marL="0">
@@ -7252,7 +7552,7 @@
             <a:r>
               <a:rPr lang="en-US" sz="3000" b="1" dirty="0">
                 <a:solidFill>
-                  <a:srgbClr val="E4E0D3"/>
+                  <a:srgbClr val="C2BAA6"/>
                 </a:solidFill>
                 <a:latin typeface="Cambria" pitchFamily="34" charset="0"/>
                 <a:ea typeface="Cambria" pitchFamily="34" charset="-122"/>
@@ -7311,17 +7611,17 @@
         </p:nvSpPr>
         <p:spPr>
           <a:xfrm>
-            <a:off x="6858000" y="5129784"/>
-            <a:ext cx="4480560" cy="960120"/>
-          </a:xfrm>
-          <a:prstGeom prst="rect">
-            <a:avLst/>
-          </a:prstGeom>
-          <a:noFill/>
-          <a:ln/>
-        </p:spPr>
-        <p:txBody>
-          <a:bodyPr wrap="square" lIns="0" tIns="0" rIns="0" bIns="0" rtlCol="0" anchor="ctr"/>
+            <a:off x="6858000" y="5111496"/>
+            <a:ext cx="4480560" cy="1005840"/>
+          </a:xfrm>
+          <a:prstGeom prst="rect">
+            <a:avLst/>
+          </a:prstGeom>
+          <a:noFill/>
+          <a:ln/>
+        </p:spPr>
+        <p:txBody>
+          <a:bodyPr wrap="square" lIns="0" tIns="0" rIns="0" bIns="0" rtlCol="0" anchor="t"/>
           <a:lstStyle/>
           <a:p>
             <a:pPr indent="0" marL="0">
@@ -7339,7 +7639,7 @@
                 <a:ea typeface="Calibri" pitchFamily="34" charset="-122"/>
                 <a:cs typeface="Calibri" pitchFamily="34" charset="-120"/>
               </a:rPr>
-              <a:t>Capped to real capacity — 12 mandatory, 24 scheduled, 48 watched per quarter.</a:t>
+              <a:t>Capped to real capacity: 12 mandatory, 24 scheduled, 48 watched per quarter.</a:t>
             </a:r>
             <a:endParaRPr lang="en-US" sz="1200" dirty="0"/>
           </a:p>
@@ -7381,6 +7681,54 @@
               <a:t>No installed hardware. Every input is free and public.</a:t>
             </a:r>
             <a:endParaRPr lang="en-US" sz="1500" dirty="0"/>
+          </a:p>
+        </p:txBody>
+      </p:sp>
+      <p:sp>
+        <p:nvSpPr>
+          <p:cNvPr id="25" name="Slide Number Placeholder 0"/>
+          <p:cNvSpPr>
+            <a:spLocks noGrp="1"/>
+          </p:cNvSpPr>
+          <p:nvPr>
+            <p:ph type="sldNum" sz="quarter" idx="4294967295"/>
+          </p:nvPr>
+        </p:nvSpPr>
+        <p:spPr>
+          <a:xfrm>
+            <a:off x="11622024" y="6510528"/>
+            <a:ext cx="800000" cy="300000"/>
+          </a:xfrm>
+          <a:prstGeom prst="rect">
+            <a:avLst/>
+          </a:prstGeom>
+          <a:extLst>
+            <a:ext uri="{C572A759-6A51-4108-AA02-DFA0A04FC94B}">
+              <ma14:wrappingTextBoxFlag xmlns:ma14="http://schemas.microsoft.com/office/mac/drawingml/2011/main" val="0"/>
+            </a:ext>
+          </a:extLst>
+        </p:spPr>
+        <p:txBody>
+          <a:bodyPr/>
+          <a:lstStyle>
+            <a:lvl1pPr>
+              <a:defRPr sz="900">
+                <a:solidFill>
+                  <a:srgbClr val="B3AC9A"/>
+                </a:solidFill>
+                <a:latin typeface="Courier New"/>
+                <a:ea typeface="Courier New"/>
+                <a:cs typeface="Courier New"/>
+              </a:defRPr>
+            </a:lvl1pPr>
+          </a:lstStyle>
+          <a:p>
+            <a:pPr algn="l"/>
+            <a:fld id="{F7021451-1387-4CA6-816F-3879F97B5CBC}" type="slidenum">
+              <a:rPr b="0" lang="en-US"/>
+              <a:t>5</a:t>
+            </a:fld>
+            <a:endParaRPr lang="en-US"/>
           </a:p>
         </p:txBody>
       </p:sp>
@@ -7434,10 +7782,10 @@
           <a:ln/>
         </p:spPr>
         <p:txBody>
-          <a:bodyPr wrap="square" lIns="0" tIns="0" rIns="0" bIns="0" rtlCol="0" anchor="ctr"/>
-          <a:lstStyle/>
-          <a:p>
-            <a:pPr indent="0" marL="0">
+          <a:bodyPr wrap="square" lIns="0" tIns="0" rIns="0" bIns="0" rtlCol="0" anchor="t"/>
+          <a:lstStyle/>
+          <a:p>
+            <a:pPr algn="l" indent="0" marL="0">
               <a:buNone/>
             </a:pPr>
             <a:r>
@@ -7533,7 +7881,7 @@
                 <a:ea typeface="Calibri" pitchFamily="34" charset="-122"/>
                 <a:cs typeface="Calibri" pitchFamily="34" charset="-120"/>
               </a:rPr>
-              <a:t>Vermont structure 101412003714121: the official rating fell from 8 to 3 in 2025. The model, frozen at 2015 and blind to everything after, had it inside the top-15% alert budget 9 years earlier — and kept it there every year since.</a:t>
+              <a:t>Vermont structure 101412003714121: the official rating fell from 8 to 3 in 2025. The model, frozen at 2015 and blind to everything after, had it inside the top-15% alert budget 9 years earlier, and kept it there every year since.</a:t>
             </a:r>
             <a:endParaRPr lang="en-US" sz="1450" dirty="0"/>
           </a:p>
@@ -7919,6 +8267,54 @@
               <a:t>Real federal data. The model never saw a single post-2018 filing.</a:t>
             </a:r>
             <a:endParaRPr lang="en-US" sz="1000" dirty="0"/>
+          </a:p>
+        </p:txBody>
+      </p:sp>
+      <p:sp>
+        <p:nvSpPr>
+          <p:cNvPr id="25" name="Slide Number Placeholder 0"/>
+          <p:cNvSpPr>
+            <a:spLocks noGrp="1"/>
+          </p:cNvSpPr>
+          <p:nvPr>
+            <p:ph type="sldNum" sz="quarter" idx="4294967295"/>
+          </p:nvPr>
+        </p:nvSpPr>
+        <p:spPr>
+          <a:xfrm>
+            <a:off x="11622024" y="6510528"/>
+            <a:ext cx="800000" cy="300000"/>
+          </a:xfrm>
+          <a:prstGeom prst="rect">
+            <a:avLst/>
+          </a:prstGeom>
+          <a:extLst>
+            <a:ext uri="{C572A759-6A51-4108-AA02-DFA0A04FC94B}">
+              <ma14:wrappingTextBoxFlag xmlns:ma14="http://schemas.microsoft.com/office/mac/drawingml/2011/main" val="0"/>
+            </a:ext>
+          </a:extLst>
+        </p:spPr>
+        <p:txBody>
+          <a:bodyPr/>
+          <a:lstStyle>
+            <a:lvl1pPr>
+              <a:defRPr sz="900">
+                <a:solidFill>
+                  <a:srgbClr val="B3AC9A"/>
+                </a:solidFill>
+                <a:latin typeface="Courier New"/>
+                <a:ea typeface="Courier New"/>
+                <a:cs typeface="Courier New"/>
+              </a:defRPr>
+            </a:lvl1pPr>
+          </a:lstStyle>
+          <a:p>
+            <a:pPr algn="l"/>
+            <a:fld id="{F7021451-1387-4CA6-816F-3879F97B5CBC}" type="slidenum">
+              <a:rPr b="0" lang="en-US"/>
+              <a:t>6</a:t>
+            </a:fld>
+            <a:endParaRPr lang="en-US"/>
           </a:p>
         </p:txBody>
       </p:sp>
@@ -7972,10 +8368,10 @@
           <a:ln/>
         </p:spPr>
         <p:txBody>
-          <a:bodyPr wrap="square" lIns="0" tIns="0" rIns="0" bIns="0" rtlCol="0" anchor="ctr"/>
-          <a:lstStyle/>
-          <a:p>
-            <a:pPr indent="0" marL="0">
+          <a:bodyPr wrap="square" lIns="0" tIns="0" rIns="0" bIns="0" rtlCol="0" anchor="t"/>
+          <a:lstStyle/>
+          <a:p>
+            <a:pPr algn="l" indent="0" marL="0">
               <a:buNone/>
             </a:pPr>
             <a:r>
@@ -8071,7 +8467,7 @@
                 <a:ea typeface="Calibri" pitchFamily="34" charset="-122"/>
                 <a:cs typeface="Calibri" pitchFamily="34" charset="-120"/>
               </a:rPr>
-              <a:t>1,835 "the record was forced to catch up" events were mined from the trajectories: sudden drops of two or more rating steps, or closures. The 166 that happen after 2018 are pure holdout — the model was frozen in 2015 and never saw them.</a:t>
+              <a:t>1,835 “the record was forced to catch up” events were mined from the trajectories: sudden drops of two or more rating steps, or closures. The 166 that happen after 2018 are pure holdout: the model was frozen in 2015 and never saw them.</a:t>
             </a:r>
             <a:endParaRPr lang="en-US" sz="1400" dirty="0"/>
           </a:p>
@@ -8147,7 +8543,7 @@
               <a:buNone/>
             </a:pPr>
             <a:r>
-              <a:rPr lang="en-US" sz="2200" b="1" dirty="0">
+              <a:rPr lang="en-US" sz="2300" b="1" dirty="0">
                 <a:solidFill>
                   <a:srgbClr val="16204A"/>
                 </a:solidFill>
@@ -8157,7 +8553,7 @@
               </a:rPr>
               <a:t>234,801</a:t>
             </a:r>
-            <a:endParaRPr lang="en-US" sz="2200" dirty="0"/>
+            <a:endParaRPr lang="en-US" sz="2300" dirty="0"/>
           </a:p>
         </p:txBody>
       </p:sp>
@@ -8169,17 +8565,17 @@
         </p:nvSpPr>
         <p:spPr>
           <a:xfrm>
-            <a:off x="731520" y="3520440"/>
-            <a:ext cx="1704442" cy="777240"/>
-          </a:xfrm>
-          <a:prstGeom prst="rect">
-            <a:avLst/>
-          </a:prstGeom>
-          <a:noFill/>
-          <a:ln/>
-        </p:spPr>
-        <p:txBody>
-          <a:bodyPr wrap="square" lIns="0" tIns="0" rIns="0" bIns="0" rtlCol="0" anchor="ctr"/>
+            <a:off x="731520" y="3310128"/>
+            <a:ext cx="1704442" cy="960120"/>
+          </a:xfrm>
+          <a:prstGeom prst="rect">
+            <a:avLst/>
+          </a:prstGeom>
+          <a:noFill/>
+          <a:ln/>
+        </p:spPr>
+        <p:txBody>
+          <a:bodyPr wrap="square" lIns="0" tIns="0" rIns="0" bIns="0" rtlCol="0" anchor="t"/>
           <a:lstStyle/>
           <a:p>
             <a:pPr indent="0" marL="0">
@@ -8293,7 +8689,7 @@
               <a:buNone/>
             </a:pPr>
             <a:r>
-              <a:rPr lang="en-US" sz="2800" b="1" dirty="0">
+              <a:rPr lang="en-US" sz="2300" b="1" dirty="0">
                 <a:solidFill>
                   <a:srgbClr val="16204A"/>
                 </a:solidFill>
@@ -8303,7 +8699,7 @@
               </a:rPr>
               <a:t>0.7</a:t>
             </a:r>
-            <a:endParaRPr lang="en-US" sz="2800" dirty="0"/>
+            <a:endParaRPr lang="en-US" sz="2300" dirty="0"/>
           </a:p>
         </p:txBody>
       </p:sp>
@@ -8315,17 +8711,17 @@
         </p:nvSpPr>
         <p:spPr>
           <a:xfrm>
-            <a:off x="2911450" y="3520440"/>
-            <a:ext cx="1704442" cy="777240"/>
-          </a:xfrm>
-          <a:prstGeom prst="rect">
-            <a:avLst/>
-          </a:prstGeom>
-          <a:noFill/>
-          <a:ln/>
-        </p:spPr>
-        <p:txBody>
-          <a:bodyPr wrap="square" lIns="0" tIns="0" rIns="0" bIns="0" rtlCol="0" anchor="ctr"/>
+            <a:off x="2911450" y="3310128"/>
+            <a:ext cx="1704442" cy="960120"/>
+          </a:xfrm>
+          <a:prstGeom prst="rect">
+            <a:avLst/>
+          </a:prstGeom>
+          <a:noFill/>
+          <a:ln/>
+        </p:spPr>
+        <p:txBody>
+          <a:bodyPr wrap="square" lIns="0" tIns="0" rIns="0" bIns="0" rtlCol="0" anchor="t"/>
           <a:lstStyle/>
           <a:p>
             <a:pPr indent="0" marL="0">
@@ -8439,7 +8835,7 @@
               <a:buNone/>
             </a:pPr>
             <a:r>
-              <a:rPr lang="en-US" sz="2800" b="1" dirty="0">
+              <a:rPr lang="en-US" sz="2300" b="1" dirty="0">
                 <a:solidFill>
                   <a:srgbClr val="16204A"/>
                 </a:solidFill>
@@ -8449,7 +8845,7 @@
               </a:rPr>
               <a:t>89%</a:t>
             </a:r>
-            <a:endParaRPr lang="en-US" sz="2800" dirty="0"/>
+            <a:endParaRPr lang="en-US" sz="2300" dirty="0"/>
           </a:p>
         </p:txBody>
       </p:sp>
@@ -8461,17 +8857,17 @@
         </p:nvSpPr>
         <p:spPr>
           <a:xfrm>
-            <a:off x="5091379" y="3520440"/>
-            <a:ext cx="1704442" cy="777240"/>
-          </a:xfrm>
-          <a:prstGeom prst="rect">
-            <a:avLst/>
-          </a:prstGeom>
-          <a:noFill/>
-          <a:ln/>
-        </p:spPr>
-        <p:txBody>
-          <a:bodyPr wrap="square" lIns="0" tIns="0" rIns="0" bIns="0" rtlCol="0" anchor="ctr"/>
+            <a:off x="5091379" y="3310128"/>
+            <a:ext cx="1704442" cy="960120"/>
+          </a:xfrm>
+          <a:prstGeom prst="rect">
+            <a:avLst/>
+          </a:prstGeom>
+          <a:noFill/>
+          <a:ln/>
+        </p:spPr>
+        <p:txBody>
+          <a:bodyPr wrap="square" lIns="0" tIns="0" rIns="0" bIns="0" rtlCol="0" anchor="t"/>
           <a:lstStyle/>
           <a:p>
             <a:pPr indent="0" marL="0">
@@ -8585,7 +8981,7 @@
               <a:buNone/>
             </a:pPr>
             <a:r>
-              <a:rPr lang="en-US" sz="2800" b="1" dirty="0">
+              <a:rPr lang="en-US" sz="2300" b="1" dirty="0">
                 <a:solidFill>
                   <a:srgbClr val="C6283C"/>
                 </a:solidFill>
@@ -8595,7 +8991,7 @@
               </a:rPr>
               <a:t>23%</a:t>
             </a:r>
-            <a:endParaRPr lang="en-US" sz="2800" dirty="0"/>
+            <a:endParaRPr lang="en-US" sz="2300" dirty="0"/>
           </a:p>
         </p:txBody>
       </p:sp>
@@ -8607,17 +9003,17 @@
         </p:nvSpPr>
         <p:spPr>
           <a:xfrm>
-            <a:off x="7271309" y="3520440"/>
-            <a:ext cx="1704442" cy="777240"/>
-          </a:xfrm>
-          <a:prstGeom prst="rect">
-            <a:avLst/>
-          </a:prstGeom>
-          <a:noFill/>
-          <a:ln/>
-        </p:spPr>
-        <p:txBody>
-          <a:bodyPr wrap="square" lIns="0" tIns="0" rIns="0" bIns="0" rtlCol="0" anchor="ctr"/>
+            <a:off x="7271309" y="3310128"/>
+            <a:ext cx="1704442" cy="960120"/>
+          </a:xfrm>
+          <a:prstGeom prst="rect">
+            <a:avLst/>
+          </a:prstGeom>
+          <a:noFill/>
+          <a:ln/>
+        </p:spPr>
+        <p:txBody>
+          <a:bodyPr wrap="square" lIns="0" tIns="0" rIns="0" bIns="0" rtlCol="0" anchor="t"/>
           <a:lstStyle/>
           <a:p>
             <a:pPr indent="0" marL="0">
@@ -8731,7 +9127,7 @@
               <a:buNone/>
             </a:pPr>
             <a:r>
-              <a:rPr lang="en-US" sz="2200" b="1" dirty="0">
+              <a:rPr lang="en-US" sz="2300" b="1" dirty="0">
                 <a:solidFill>
                   <a:srgbClr val="C6283C"/>
                 </a:solidFill>
@@ -8741,7 +9137,7 @@
               </a:rPr>
               <a:t>3.5 yrs</a:t>
             </a:r>
-            <a:endParaRPr lang="en-US" sz="2200" dirty="0"/>
+            <a:endParaRPr lang="en-US" sz="2300" dirty="0"/>
           </a:p>
         </p:txBody>
       </p:sp>
@@ -8753,17 +9149,17 @@
         </p:nvSpPr>
         <p:spPr>
           <a:xfrm>
-            <a:off x="9451238" y="3520440"/>
-            <a:ext cx="1704442" cy="777240"/>
-          </a:xfrm>
-          <a:prstGeom prst="rect">
-            <a:avLst/>
-          </a:prstGeom>
-          <a:noFill/>
-          <a:ln/>
-        </p:spPr>
-        <p:txBody>
-          <a:bodyPr wrap="square" lIns="0" tIns="0" rIns="0" bIns="0" rtlCol="0" anchor="ctr"/>
+            <a:off x="9451238" y="3310128"/>
+            <a:ext cx="1704442" cy="960120"/>
+          </a:xfrm>
+          <a:prstGeom prst="rect">
+            <a:avLst/>
+          </a:prstGeom>
+          <a:noFill/>
+          <a:ln/>
+        </p:spPr>
+        <p:txBody>
+          <a:bodyPr wrap="square" lIns="0" tIns="0" rIns="0" bIns="0" rtlCol="0" anchor="t"/>
           <a:lstStyle/>
           <a:p>
             <a:pPr indent="0" marL="0">
@@ -8910,6 +9306,54 @@
               <a:t>A model that flags everything catches everything and helps nobody. Ours is scored the way an inspection team actually works: a fixed number of alerts per quarter, and we count only the real failures that fall inside it.</a:t>
             </a:r>
             <a:endParaRPr lang="en-US" sz="1300" dirty="0"/>
+          </a:p>
+        </p:txBody>
+      </p:sp>
+      <p:sp>
+        <p:nvSpPr>
+          <p:cNvPr id="25" name="Slide Number Placeholder 0"/>
+          <p:cNvSpPr>
+            <a:spLocks noGrp="1"/>
+          </p:cNvSpPr>
+          <p:nvPr>
+            <p:ph type="sldNum" sz="quarter" idx="4294967295"/>
+          </p:nvPr>
+        </p:nvSpPr>
+        <p:spPr>
+          <a:xfrm>
+            <a:off x="11622024" y="6510528"/>
+            <a:ext cx="800000" cy="300000"/>
+          </a:xfrm>
+          <a:prstGeom prst="rect">
+            <a:avLst/>
+          </a:prstGeom>
+          <a:extLst>
+            <a:ext uri="{C572A759-6A51-4108-AA02-DFA0A04FC94B}">
+              <ma14:wrappingTextBoxFlag xmlns:ma14="http://schemas.microsoft.com/office/mac/drawingml/2011/main" val="0"/>
+            </a:ext>
+          </a:extLst>
+        </p:spPr>
+        <p:txBody>
+          <a:bodyPr/>
+          <a:lstStyle>
+            <a:lvl1pPr>
+              <a:defRPr sz="900">
+                <a:solidFill>
+                  <a:srgbClr val="B3AC9A"/>
+                </a:solidFill>
+                <a:latin typeface="Courier New"/>
+                <a:ea typeface="Courier New"/>
+                <a:cs typeface="Courier New"/>
+              </a:defRPr>
+            </a:lvl1pPr>
+          </a:lstStyle>
+          <a:p>
+            <a:pPr algn="l"/>
+            <a:fld id="{F7021451-1387-4CA6-816F-3879F97B5CBC}" type="slidenum">
+              <a:rPr b="0" lang="en-US"/>
+              <a:t>7</a:t>
+            </a:fld>
+            <a:endParaRPr lang="en-US"/>
           </a:p>
         </p:txBody>
       </p:sp>
@@ -8954,17 +9398,15 @@
           <p:nvPr/>
         </p:nvPicPr>
         <p:blipFill>
-          <a:blip r:embed="rId1">
-            <a:alphaModFix amt="82000"/>
-          </a:blip>
+          <a:blip r:embed="rId1"/>
           <a:stretch>
             <a:fillRect/>
           </a:stretch>
         </p:blipFill>
         <p:spPr>
           <a:xfrm>
-            <a:off x="0" y="822960"/>
-            <a:ext cx="12188952" cy="5486400"/>
+            <a:off x="1572768" y="896112"/>
+            <a:ext cx="9034272" cy="4937760"/>
           </a:xfrm>
           <a:prstGeom prst="rect">
             <a:avLst/>
@@ -8980,7 +9422,7 @@
         <p:spPr>
           <a:xfrm>
             <a:off x="0" y="0"/>
-            <a:ext cx="12188952" cy="960120"/>
+            <a:ext cx="12188952" cy="868680"/>
           </a:xfrm>
           <a:prstGeom prst="rect">
             <a:avLst/>
@@ -8999,7 +9441,7 @@
         </p:nvSpPr>
         <p:spPr>
           <a:xfrm>
-            <a:off x="594360" y="274320"/>
+            <a:off x="594360" y="457200"/>
             <a:ext cx="5486400" cy="228600"/>
           </a:xfrm>
           <a:prstGeom prst="rect">
@@ -9009,16 +9451,16 @@
           <a:ln/>
         </p:spPr>
         <p:txBody>
-          <a:bodyPr wrap="square" lIns="0" tIns="0" rIns="0" bIns="0" rtlCol="0" anchor="ctr"/>
-          <a:lstStyle/>
-          <a:p>
-            <a:pPr indent="0" marL="0">
+          <a:bodyPr wrap="square" lIns="0" tIns="0" rIns="0" bIns="0" rtlCol="0" anchor="t"/>
+          <a:lstStyle/>
+          <a:p>
+            <a:pPr algn="l" indent="0" marL="0">
               <a:buNone/>
             </a:pPr>
             <a:r>
               <a:rPr lang="en-US" sz="1050" spc="120" kern="0" dirty="0">
                 <a:solidFill>
-                  <a:srgbClr val="C6283C"/>
+                  <a:srgbClr val="E4607A"/>
                 </a:solidFill>
                 <a:latin typeface="Courier New" pitchFamily="34" charset="0"/>
                 <a:ea typeface="Courier New" pitchFamily="34" charset="-122"/>
@@ -9038,7 +9480,7 @@
         </p:nvSpPr>
         <p:spPr>
           <a:xfrm>
-            <a:off x="594360" y="502920"/>
+            <a:off x="594360" y="777240"/>
             <a:ext cx="10789920" cy="914400"/>
           </a:xfrm>
           <a:prstGeom prst="rect">
@@ -9401,6 +9843,54 @@
               <a:t>NO BACKEND REQUIRED</a:t>
             </a:r>
             <a:endParaRPr lang="en-US" sz="850" dirty="0"/>
+          </a:p>
+        </p:txBody>
+      </p:sp>
+      <p:sp>
+        <p:nvSpPr>
+          <p:cNvPr id="25" name="Slide Number Placeholder 0"/>
+          <p:cNvSpPr>
+            <a:spLocks noGrp="1"/>
+          </p:cNvSpPr>
+          <p:nvPr>
+            <p:ph type="sldNum" sz="quarter" idx="4294967295"/>
+          </p:nvPr>
+        </p:nvSpPr>
+        <p:spPr>
+          <a:xfrm>
+            <a:off x="11622024" y="6510528"/>
+            <a:ext cx="800000" cy="300000"/>
+          </a:xfrm>
+          <a:prstGeom prst="rect">
+            <a:avLst/>
+          </a:prstGeom>
+          <a:extLst>
+            <a:ext uri="{C572A759-6A51-4108-AA02-DFA0A04FC94B}">
+              <ma14:wrappingTextBoxFlag xmlns:ma14="http://schemas.microsoft.com/office/mac/drawingml/2011/main" val="0"/>
+            </a:ext>
+          </a:extLst>
+        </p:spPr>
+        <p:txBody>
+          <a:bodyPr/>
+          <a:lstStyle>
+            <a:lvl1pPr>
+              <a:defRPr sz="900">
+                <a:solidFill>
+                  <a:srgbClr val="5C6795"/>
+                </a:solidFill>
+                <a:latin typeface="Courier New"/>
+                <a:ea typeface="Courier New"/>
+                <a:cs typeface="Courier New"/>
+              </a:defRPr>
+            </a:lvl1pPr>
+          </a:lstStyle>
+          <a:p>
+            <a:pPr algn="l"/>
+            <a:fld id="{F7021451-1387-4CA6-816F-3879F97B5CBC}" type="slidenum">
+              <a:rPr b="0" lang="en-US"/>
+              <a:t>8</a:t>
+            </a:fld>
+            <a:endParaRPr lang="en-US"/>
           </a:p>
         </p:txBody>
       </p:sp>
@@ -9454,10 +9944,10 @@
           <a:ln/>
         </p:spPr>
         <p:txBody>
-          <a:bodyPr wrap="square" lIns="0" tIns="0" rIns="0" bIns="0" rtlCol="0" anchor="ctr"/>
-          <a:lstStyle/>
-          <a:p>
-            <a:pPr indent="0" marL="0">
+          <a:bodyPr wrap="square" lIns="0" tIns="0" rIns="0" bIns="0" rtlCol="0" anchor="t"/>
+          <a:lstStyle/>
+          <a:p>
+            <a:pPr algn="l" indent="0" marL="0">
               <a:buNone/>
             </a:pPr>
             <a:r>
@@ -9623,7 +10113,7 @@
         </p:nvSpPr>
         <p:spPr>
           <a:xfrm>
-            <a:off x="13560552" y="1673352"/>
+            <a:off x="7159752" y="1673352"/>
             <a:ext cx="2743200" cy="237744"/>
           </a:xfrm>
           <a:prstGeom prst="rect">
@@ -9663,7 +10153,7 @@
         <p:spPr>
           <a:xfrm>
             <a:off x="594360" y="1984248"/>
-            <a:ext cx="10698480" cy="786384"/>
+            <a:ext cx="10698480" cy="731520"/>
           </a:xfrm>
           <a:prstGeom prst="rect">
             <a:avLst/>
@@ -9805,7 +10295,7 @@
         </p:nvSpPr>
         <p:spPr>
           <a:xfrm>
-            <a:off x="758952" y="2953512"/>
+            <a:off x="758952" y="2898648"/>
             <a:ext cx="2651760" cy="457200"/>
           </a:xfrm>
           <a:prstGeom prst="rect">
@@ -9844,7 +10334,7 @@
         </p:nvSpPr>
         <p:spPr>
           <a:xfrm>
-            <a:off x="3593592" y="2953512"/>
+            <a:off x="3593592" y="2898648"/>
             <a:ext cx="3383280" cy="502920"/>
           </a:xfrm>
           <a:prstGeom prst="rect">
@@ -9886,7 +10376,7 @@
         </p:nvSpPr>
         <p:spPr>
           <a:xfrm>
-            <a:off x="7159752" y="2953512"/>
+            <a:off x="7159752" y="2898648"/>
             <a:ext cx="3931920" cy="502920"/>
           </a:xfrm>
           <a:prstGeom prst="rect">
@@ -9928,8 +10418,8 @@
         </p:nvSpPr>
         <p:spPr>
           <a:xfrm>
-            <a:off x="594360" y="3557016"/>
-            <a:ext cx="10698480" cy="786384"/>
+            <a:off x="594360" y="3447288"/>
+            <a:ext cx="10698480" cy="731520"/>
           </a:xfrm>
           <a:prstGeom prst="rect">
             <a:avLst/>
@@ -9948,7 +10438,7 @@
         </p:nvSpPr>
         <p:spPr>
           <a:xfrm>
-            <a:off x="758952" y="3739896"/>
+            <a:off x="758952" y="3630168"/>
             <a:ext cx="2651760" cy="457200"/>
           </a:xfrm>
           <a:prstGeom prst="rect">
@@ -9987,7 +10477,7 @@
         </p:nvSpPr>
         <p:spPr>
           <a:xfrm>
-            <a:off x="3593592" y="3739896"/>
+            <a:off x="3593592" y="3630168"/>
             <a:ext cx="3383280" cy="502920"/>
           </a:xfrm>
           <a:prstGeom prst="rect">
@@ -10029,7 +10519,7 @@
         </p:nvSpPr>
         <p:spPr>
           <a:xfrm>
-            <a:off x="7159752" y="3739896"/>
+            <a:off x="7159752" y="3630168"/>
             <a:ext cx="3931920" cy="502920"/>
           </a:xfrm>
           <a:prstGeom prst="rect">
@@ -10071,7 +10561,7 @@
         </p:nvSpPr>
         <p:spPr>
           <a:xfrm>
-            <a:off x="758952" y="4526280"/>
+            <a:off x="758952" y="4361688"/>
             <a:ext cx="2651760" cy="457200"/>
           </a:xfrm>
           <a:prstGeom prst="rect">
@@ -10110,7 +10600,7 @@
         </p:nvSpPr>
         <p:spPr>
           <a:xfrm>
-            <a:off x="3593592" y="4526280"/>
+            <a:off x="3593592" y="4361688"/>
             <a:ext cx="3383280" cy="502920"/>
           </a:xfrm>
           <a:prstGeom prst="rect">
@@ -10152,7 +10642,7 @@
         </p:nvSpPr>
         <p:spPr>
           <a:xfrm>
-            <a:off x="7159752" y="4526280"/>
+            <a:off x="7159752" y="4361688"/>
             <a:ext cx="3931920" cy="502920"/>
           </a:xfrm>
           <a:prstGeom prst="rect">
@@ -10194,8 +10684,8 @@
         </p:nvSpPr>
         <p:spPr>
           <a:xfrm>
-            <a:off x="594360" y="5358384"/>
-            <a:ext cx="10698480" cy="1371600"/>
+            <a:off x="594360" y="5166360"/>
+            <a:ext cx="10698480" cy="1234440"/>
           </a:xfrm>
           <a:prstGeom prst="rect">
             <a:avLst/>
@@ -10219,7 +10709,7 @@
         </p:nvSpPr>
         <p:spPr>
           <a:xfrm>
-            <a:off x="822960" y="5522976"/>
+            <a:off x="822960" y="5330952"/>
             <a:ext cx="2651760" cy="320040"/>
           </a:xfrm>
           <a:prstGeom prst="rect">
@@ -10258,7 +10748,7 @@
         </p:nvSpPr>
         <p:spPr>
           <a:xfrm>
-            <a:off x="822960" y="5888736"/>
+            <a:off x="822960" y="5696712"/>
             <a:ext cx="10241280" cy="731520"/>
           </a:xfrm>
           <a:prstGeom prst="rect">
@@ -10286,9 +10776,57 @@
                 <a:ea typeface="Calibri" pitchFamily="34" charset="-122"/>
                 <a:cs typeface="Calibri" pitchFamily="34" charset="-120"/>
               </a:rPr>
-              <a:t>Audits the record itself, on 100% of an inventory, with zero installed hardware — and its output is a calibrated contradiction with a dated obligation attached, not another dashboard.</a:t>
+              <a:t>Audits the record itself, on 100% of an inventory, with zero installed hardware. Its output is a calibrated contradiction with a dated obligation attached, not another dashboard.</a:t>
             </a:r>
             <a:endParaRPr lang="en-US" sz="1350" dirty="0"/>
+          </a:p>
+        </p:txBody>
+      </p:sp>
+      <p:sp>
+        <p:nvSpPr>
+          <p:cNvPr id="25" name="Slide Number Placeholder 0"/>
+          <p:cNvSpPr>
+            <a:spLocks noGrp="1"/>
+          </p:cNvSpPr>
+          <p:nvPr>
+            <p:ph type="sldNum" sz="quarter" idx="4294967295"/>
+          </p:nvPr>
+        </p:nvSpPr>
+        <p:spPr>
+          <a:xfrm>
+            <a:off x="11622024" y="6510528"/>
+            <a:ext cx="800000" cy="300000"/>
+          </a:xfrm>
+          <a:prstGeom prst="rect">
+            <a:avLst/>
+          </a:prstGeom>
+          <a:extLst>
+            <a:ext uri="{C572A759-6A51-4108-AA02-DFA0A04FC94B}">
+              <ma14:wrappingTextBoxFlag xmlns:ma14="http://schemas.microsoft.com/office/mac/drawingml/2011/main" val="0"/>
+            </a:ext>
+          </a:extLst>
+        </p:spPr>
+        <p:txBody>
+          <a:bodyPr/>
+          <a:lstStyle>
+            <a:lvl1pPr>
+              <a:defRPr sz="900">
+                <a:solidFill>
+                  <a:srgbClr val="B3AC9A"/>
+                </a:solidFill>
+                <a:latin typeface="Courier New"/>
+                <a:ea typeface="Courier New"/>
+                <a:cs typeface="Courier New"/>
+              </a:defRPr>
+            </a:lvl1pPr>
+          </a:lstStyle>
+          <a:p>
+            <a:pPr algn="l"/>
+            <a:fld id="{F7021451-1387-4CA6-816F-3879F97B5CBC}" type="slidenum">
+              <a:rPr b="0" lang="en-US"/>
+              <a:t>9</a:t>
+            </a:fld>
+            <a:endParaRPr lang="en-US"/>
           </a:p>
         </p:txBody>
       </p:sp>

</xml_diff>

<commit_message>
Pitch and console: lead with the control result, not the raw recall
The rating-matched control changed which claim is defensible. Slide 7, the
30-second script and the Q&A now lead with the segment finding — of 108
held-out failures on structures the record still called fine, worst-recorded-
first found 0 and dissent found 25 — and state plainly that the naive baseline
wins on raw count. Added the Time Machine to the demo script, the withheld-
jurisdictions moment to the index walkthrough, and two traps: never claim we
beat the baseline outright, never rank a withheld state.

03_model.py exports the controls so the deck reads them from the artifact
rather than from prose.

Co-Authored-By: Claude Fable 5 <noreply@anthropic.com>
</commit_message>
<xml_diff>
--- a/pitch/DISSENT_Nexus_Network_Pitch.pptx
+++ b/pitch/DISSENT_Nexus_Network_Pitch.pptx
@@ -1920,7 +1920,7 @@
           <a:p>
             <a:r>
               <a:rPr lang="en-US" dirty="0"/>
-              <a:t>This is the slide a technical judge will interrogate. Emphasise: frozen model, pure holdout, budgeted alerts. The coverage number is deliberately reported below target because we refuse to retune on test years.</a:t>
+              <a:t>This is the slide a technical judge will interrogate. Frozen model, pure holdout, budgeted alerts. Do NOT claim we beat the naive baseline outright: on raw count it catches 40 of 166 and we catch 38. Claim the true and stronger thing: on the 108 failures where the record still read fine, worst-first found 0 and we found 25. Against a rating-matched blind pick we run 1.338x. Coverage is reported below target because we refuse to retune on test years.</a:t>
             </a:r>
             <a:endParaRPr lang="en-US" dirty="0"/>
           </a:p>
@@ -9051,7 +9051,7 @@
                 <a:ea typeface="Courier New" pitchFamily="34" charset="-122"/>
                 <a:cs typeface="Courier New" pitchFamily="34" charset="-120"/>
               </a:rPr>
-              <a:t>1.5× BETTER THAN CHANCE</a:t>
+              <a:t>1.34× A RATING-MATCHED PICK</a:t>
             </a:r>
             <a:endParaRPr lang="en-US" sz="800" dirty="0"/>
           </a:p>
@@ -9211,8 +9211,8 @@
         </p:nvSpPr>
         <p:spPr>
           <a:xfrm>
-            <a:off x="594360" y="4663440"/>
-            <a:ext cx="10698480" cy="1234440"/>
+            <a:off x="594360" y="4617720"/>
+            <a:ext cx="10698480" cy="1600200"/>
           </a:xfrm>
           <a:prstGeom prst="rect">
             <a:avLst/>
@@ -9236,7 +9236,7 @@
         </p:nvSpPr>
         <p:spPr>
           <a:xfrm>
-            <a:off x="822960" y="4800600"/>
+            <a:off x="822960" y="4736592"/>
             <a:ext cx="10241280" cy="274320"/>
           </a:xfrm>
           <a:prstGeom prst="rect">
@@ -9261,7 +9261,7 @@
                 <a:ea typeface="Courier New" pitchFamily="34" charset="-122"/>
                 <a:cs typeface="Courier New" pitchFamily="34" charset="-120"/>
               </a:rPr>
-              <a:t>Why an alert budget, not an accuracy score</a:t>
+              <a:t>“Why not just sort by the worst recorded rating?”</a:t>
             </a:r>
             <a:endParaRPr lang="en-US" sz="1050" dirty="0"/>
           </a:p>
@@ -9275,27 +9275,27 @@
         </p:nvSpPr>
         <p:spPr>
           <a:xfrm>
-            <a:off x="822960" y="5120640"/>
-            <a:ext cx="10241280" cy="640080"/>
-          </a:xfrm>
-          <a:prstGeom prst="rect">
-            <a:avLst/>
-          </a:prstGeom>
-          <a:noFill/>
-          <a:ln/>
-        </p:spPr>
-        <p:txBody>
-          <a:bodyPr wrap="square" lIns="0" tIns="0" rIns="0" bIns="0" rtlCol="0" anchor="ctr"/>
+            <a:off x="822960" y="5029200"/>
+            <a:ext cx="6766560" cy="1005840"/>
+          </a:xfrm>
+          <a:prstGeom prst="rect">
+            <a:avLst/>
+          </a:prstGeom>
+          <a:noFill/>
+          <a:ln/>
+        </p:spPr>
+        <p:txBody>
+          <a:bodyPr wrap="square" lIns="0" tIns="0" rIns="0" bIns="0" rtlCol="0" anchor="t"/>
           <a:lstStyle/>
           <a:p>
             <a:pPr indent="0" marL="0">
               <a:lnSpc>
-                <a:spcPts val="1700"/>
+                <a:spcPts val="1600"/>
               </a:lnSpc>
               <a:buNone/>
             </a:pPr>
             <a:r>
-              <a:rPr lang="en-US" sz="1300" dirty="0">
+              <a:rPr lang="en-US" sz="1250" dirty="0">
                 <a:solidFill>
                   <a:srgbClr val="20263E"/>
                 </a:solidFill>
@@ -9303,9 +9303,162 @@
                 <a:ea typeface="Calibri" pitchFamily="34" charset="-122"/>
                 <a:cs typeface="Calibri" pitchFamily="34" charset="-120"/>
               </a:rPr>
-              <a:t>A model that flags everything catches everything and helps nobody. Ours is scored the way an inspection team actually works: a fixed number of alerts per quarter, and we count only the real failures that fall inside it.</a:t>
-            </a:r>
-            <a:endParaRPr lang="en-US" sz="1300" dirty="0"/>
+              <a:t>Because it can only ever point at bridges you already worry about. Of the 166 held-out failures, 58 were on structures the record already called bad — worst-first finds 40 of those, because that ranking is nearly a definition of the answer. The other 108 were on structures the paperwork still called fine.</a:t>
+            </a:r>
+            <a:endParaRPr lang="en-US" sz="1250" dirty="0"/>
+          </a:p>
+        </p:txBody>
+      </p:sp>
+      <p:sp>
+        <p:nvSpPr>
+          <p:cNvPr id="28" name="Shape 26"/>
+          <p:cNvSpPr/>
+          <p:nvPr/>
+        </p:nvSpPr>
+        <p:spPr>
+          <a:xfrm>
+            <a:off x="7909560" y="4992624"/>
+            <a:ext cx="3337560" cy="1097280"/>
+          </a:xfrm>
+          <a:prstGeom prst="rect">
+            <a:avLst/>
+          </a:prstGeom>
+          <a:solidFill>
+            <a:srgbClr val="F4F1EA"/>
+          </a:solidFill>
+          <a:ln/>
+        </p:spPr>
+      </p:sp>
+      <p:sp>
+        <p:nvSpPr>
+          <p:cNvPr id="29" name="Text 27"/>
+          <p:cNvSpPr txBox="1"/>
+          <p:nvPr/>
+        </p:nvSpPr>
+        <p:spPr>
+          <a:xfrm>
+            <a:off x="8074152" y="5074920"/>
+            <a:ext cx="3017520" cy="256032"/>
+          </a:xfrm>
+          <a:prstGeom prst="rect">
+            <a:avLst/>
+          </a:prstGeom>
+          <a:noFill/>
+          <a:ln/>
+        </p:spPr>
+        <p:txBody>
+          <a:bodyPr wrap="square" lIns="0" tIns="0" rIns="0" bIns="0" rtlCol="0" anchor="ctr"/>
+          <a:lstStyle/>
+          <a:p>
+            <a:pPr indent="0" marL="0">
+              <a:buNone/>
+            </a:pPr>
+            <a:r>
+              <a:rPr lang="en-US" sz="750" spc="50" kern="0" dirty="0">
+                <a:solidFill>
+                  <a:srgbClr val="6A7088"/>
+                </a:solidFill>
+                <a:latin typeface="Courier New" pitchFamily="34" charset="0"/>
+                <a:ea typeface="Courier New" pitchFamily="34" charset="-122"/>
+                <a:cs typeface="Courier New" pitchFamily="34" charset="-120"/>
+              </a:rPr>
+              <a:t>ON THE 108 FAILURES THE RECORD STILL CALLED FINE</a:t>
+            </a:r>
+            <a:endParaRPr lang="en-US" sz="750" dirty="0"/>
+          </a:p>
+        </p:txBody>
+      </p:sp>
+      <p:sp>
+        <p:nvSpPr>
+          <p:cNvPr id="30" name="Text 28"/>
+          <p:cNvSpPr txBox="1"/>
+          <p:nvPr/>
+        </p:nvSpPr>
+        <p:spPr>
+          <a:xfrm>
+            <a:off x="8074152" y="5358384"/>
+            <a:ext cx="3017520" cy="658368"/>
+          </a:xfrm>
+          <a:prstGeom prst="rect">
+            <a:avLst/>
+          </a:prstGeom>
+          <a:noFill/>
+          <a:ln/>
+        </p:spPr>
+        <p:txBody>
+          <a:bodyPr wrap="square" lIns="0" tIns="0" rIns="0" bIns="0" rtlCol="0" anchor="t"/>
+          <a:lstStyle/>
+          <a:p>
+            <a:pPr indent="0" marL="0">
+              <a:lnSpc>
+                <a:spcPts val="1900"/>
+              </a:lnSpc>
+              <a:buNone/>
+            </a:pPr>
+            <a:r>
+              <a:rPr lang="en-US" sz="2100" b="1" dirty="0">
+                <a:solidFill>
+                  <a:srgbClr val="6A7088"/>
+                </a:solidFill>
+                <a:latin typeface="Cambria" pitchFamily="34" charset="0"/>
+                <a:ea typeface="Cambria" pitchFamily="34" charset="-122"/>
+                <a:cs typeface="Cambria" pitchFamily="34" charset="-120"/>
+              </a:rPr>
+              <a:t>0</a:t>
+            </a:r>
+            <a:pPr indent="0" marL="0">
+              <a:lnSpc>
+                <a:spcPts val="1900"/>
+              </a:lnSpc>
+              <a:buNone/>
+            </a:pPr>
+            <a:r>
+              <a:rPr lang="en-US" sz="850" dirty="0">
+                <a:solidFill>
+                  <a:srgbClr val="6A7088"/>
+                </a:solidFill>
+                <a:latin typeface="Courier New" pitchFamily="34" charset="0"/>
+                <a:ea typeface="Courier New" pitchFamily="34" charset="-122"/>
+                <a:cs typeface="Courier New" pitchFamily="34" charset="-120"/>
+              </a:rPr>
+              <a:t>  found by worst-first
+</a:t>
+            </a:r>
+            <a:pPr indent="0" marL="0">
+              <a:lnSpc>
+                <a:spcPts val="1900"/>
+              </a:lnSpc>
+              <a:buNone/>
+            </a:pPr>
+            <a:r>
+              <a:rPr lang="en-US" sz="2100" b="1" dirty="0">
+                <a:solidFill>
+                  <a:srgbClr val="C6283C"/>
+                </a:solidFill>
+                <a:latin typeface="Cambria" pitchFamily="34" charset="0"/>
+                <a:ea typeface="Cambria" pitchFamily="34" charset="-122"/>
+                <a:cs typeface="Cambria" pitchFamily="34" charset="-120"/>
+              </a:rPr>
+              <a:t>25</a:t>
+            </a:r>
+            <a:pPr indent="0" marL="0">
+              <a:lnSpc>
+                <a:spcPts val="1900"/>
+              </a:lnSpc>
+              <a:buNone/>
+            </a:pPr>
+            <a:r>
+              <a:rPr lang="en-US" sz="850" dirty="0">
+                <a:solidFill>
+                  <a:srgbClr val="C6283C"/>
+                </a:solidFill>
+                <a:latin typeface="Courier New" pitchFamily="34" charset="0"/>
+                <a:ea typeface="Courier New" pitchFamily="34" charset="-122"/>
+                <a:cs typeface="Courier New" pitchFamily="34" charset="-120"/>
+              </a:rPr>
+              <a:t>  found by dissent</a:t>
+            </a:r>
+            <a:endParaRPr lang="en-US" sz="2100" dirty="0"/>
           </a:p>
         </p:txBody>
       </p:sp>

</xml_diff>